<commit_message>
Added eeg coherence example
</commit_message>
<xml_diff>
--- a/doc/fluid_neural_data_example.pptx
+++ b/doc/fluid_neural_data_example.pptx
@@ -7,11 +7,12 @@
   <p:sldIdLst>
     <p:sldId id="256" r:id="rId2"/>
     <p:sldId id="257" r:id="rId3"/>
-    <p:sldId id="258" r:id="rId4"/>
-    <p:sldId id="260" r:id="rId5"/>
-    <p:sldId id="262" r:id="rId6"/>
-    <p:sldId id="259" r:id="rId7"/>
-    <p:sldId id="261" r:id="rId8"/>
+    <p:sldId id="263" r:id="rId4"/>
+    <p:sldId id="258" r:id="rId5"/>
+    <p:sldId id="260" r:id="rId6"/>
+    <p:sldId id="262" r:id="rId7"/>
+    <p:sldId id="259" r:id="rId8"/>
+    <p:sldId id="261" r:id="rId9"/>
   </p:sldIdLst>
   <p:sldSz cx="12192000" cy="6858000"/>
   <p:notesSz cx="6858000" cy="9144000"/>
@@ -3041,7 +3042,7 @@
           <a:p>
             <a:fld id="{5F8ED5AD-8E45-404E-BB5C-A54C85B9250C}" type="datetimeFigureOut">
               <a:rPr lang="en-GB" smtClean="0"/>
-              <a:t>12/01/2026</a:t>
+              <a:t>10/03/2026</a:t>
             </a:fld>
             <a:endParaRPr lang="en-GB"/>
           </a:p>
@@ -6290,9 +6291,10 @@
           <a:lstStyle/>
           <a:p>
             <a:r>
-              <a:rPr lang="en-GB" dirty="0"/>
-              <a:t>Summary of Previous Meetings</a:t>
-            </a:r>
+              <a:rPr lang="en-GB"/>
+              <a:t>Progress after 12/01/26</a:t>
+            </a:r>
+            <a:endParaRPr lang="en-GB" dirty="0"/>
           </a:p>
         </p:txBody>
       </p:sp>
@@ -6323,8 +6325,25 @@
             </a:pPr>
             <a:r>
               <a:rPr lang="en-GB" dirty="0"/>
-              <a:t>Discussed how fluid could be useful for neuroscience research.</a:t>
-            </a:r>
+              <a:t>Decided to use my MSc thesis output as the base for simulation</a:t>
+            </a:r>
+          </a:p>
+          <a:p>
+            <a:pPr marL="800100" lvl="1" indent="-342900">
+              <a:buFont typeface="Arial" panose="020B0604020202020204" pitchFamily="34" charset="0"/>
+              <a:buChar char="•"/>
+            </a:pPr>
+            <a:r>
+              <a:rPr lang="en-GB" dirty="0"/>
+              <a:t>Not discussed the idea with my supervisor yet</a:t>
+            </a:r>
+          </a:p>
+          <a:p>
+            <a:pPr marL="800100" lvl="1" indent="-342900">
+              <a:buFont typeface="Arial" panose="020B0604020202020204" pitchFamily="34" charset="0"/>
+              <a:buChar char="•"/>
+            </a:pPr>
+            <a:endParaRPr lang="en-GB" dirty="0"/>
           </a:p>
           <a:p>
             <a:pPr marL="342900" indent="-342900">
@@ -6333,8 +6352,63 @@
             </a:pPr>
             <a:r>
               <a:rPr lang="en-GB" dirty="0"/>
-              <a:t>Discussed using Fluid to create interactive plots for functional, structural connectivity in human brain.</a:t>
-            </a:r>
+              <a:t>Setting up of repository</a:t>
+            </a:r>
+          </a:p>
+          <a:p>
+            <a:pPr marL="800100" lvl="1" indent="-342900">
+              <a:buFont typeface="Arial" panose="020B0604020202020204" pitchFamily="34" charset="0"/>
+              <a:buChar char="•"/>
+            </a:pPr>
+            <a:r>
+              <a:rPr lang="en-GB" dirty="0"/>
+              <a:t>Created </a:t>
+            </a:r>
+            <a:r>
+              <a:rPr lang="en-GB" dirty="0" err="1"/>
+              <a:t>github</a:t>
+            </a:r>
+            <a:r>
+              <a:rPr lang="en-GB" dirty="0"/>
+              <a:t> organization, to host all relevant repositories</a:t>
+            </a:r>
+          </a:p>
+          <a:p>
+            <a:pPr marL="800100" lvl="1" indent="-342900">
+              <a:buFont typeface="Arial" panose="020B0604020202020204" pitchFamily="34" charset="0"/>
+              <a:buChar char="•"/>
+            </a:pPr>
+            <a:r>
+              <a:rPr lang="en-GB" dirty="0"/>
+              <a:t>Admin access to Roly</a:t>
+            </a:r>
+          </a:p>
+          <a:p>
+            <a:pPr marL="800100" lvl="1" indent="-342900">
+              <a:buFont typeface="Arial" panose="020B0604020202020204" pitchFamily="34" charset="0"/>
+              <a:buChar char="•"/>
+            </a:pPr>
+            <a:r>
+              <a:rPr lang="en-GB" dirty="0"/>
+              <a:t>Example website added</a:t>
+            </a:r>
+          </a:p>
+          <a:p>
+            <a:pPr marL="800100" lvl="1" indent="-342900">
+              <a:buFont typeface="Arial" panose="020B0604020202020204" pitchFamily="34" charset="0"/>
+              <a:buChar char="•"/>
+            </a:pPr>
+            <a:r>
+              <a:rPr lang="en-GB" dirty="0"/>
+              <a:t>Local building and testing of website done</a:t>
+            </a:r>
+          </a:p>
+          <a:p>
+            <a:pPr marL="800100" lvl="1" indent="-342900">
+              <a:buFont typeface="Arial" panose="020B0604020202020204" pitchFamily="34" charset="0"/>
+              <a:buChar char="•"/>
+            </a:pPr>
+            <a:endParaRPr lang="en-GB" dirty="0"/>
           </a:p>
           <a:p>
             <a:pPr marL="342900" indent="-342900">
@@ -6343,17 +6417,7 @@
             </a:pPr>
             <a:r>
               <a:rPr lang="en-GB" dirty="0"/>
-              <a:t>Using triaxial view of the brain, paired with FC and SC adjacency matrices.</a:t>
-            </a:r>
-          </a:p>
-          <a:p>
-            <a:pPr marL="342900" indent="-342900">
-              <a:buFont typeface="Arial" panose="020B0604020202020204" pitchFamily="34" charset="0"/>
-              <a:buChar char="•"/>
-            </a:pPr>
-            <a:r>
-              <a:rPr lang="en-GB" dirty="0"/>
-              <a:t>Issues with this plan:</a:t>
+              <a:t>Keeping it simple in the beginning</a:t>
             </a:r>
           </a:p>
           <a:p>
@@ -6363,7 +6427,7 @@
             </a:pPr>
             <a:r>
               <a:rPr lang="en-GB" dirty="0"/>
-              <a:t>Triaxial view difficult to incorporate with current fluid structure</a:t>
+              <a:t>Using only EEG/functional connectivity data to visualize.</a:t>
             </a:r>
           </a:p>
           <a:p>
@@ -6373,35 +6437,15 @@
             </a:pPr>
             <a:r>
               <a:rPr lang="en-GB" dirty="0"/>
-              <a:t>Data provenance not clear for FC and SC values</a:t>
-            </a:r>
-          </a:p>
-          <a:p>
-            <a:pPr marL="800100" lvl="1" indent="-342900">
-              <a:buFont typeface="Arial" panose="020B0604020202020204" pitchFamily="34" charset="0"/>
-              <a:buChar char="•"/>
-            </a:pPr>
-            <a:r>
-              <a:rPr lang="en-GB" dirty="0"/>
-              <a:t>Multidimensional data (if time, tasks conditions included)</a:t>
-            </a:r>
-          </a:p>
-          <a:p>
-            <a:pPr marL="800100" lvl="1" indent="-342900">
-              <a:buFont typeface="Arial" panose="020B0604020202020204" pitchFamily="34" charset="0"/>
-              <a:buChar char="•"/>
-            </a:pPr>
-            <a:r>
-              <a:rPr lang="en-GB" dirty="0"/>
-              <a:t>Not well-versed with fMRI, </a:t>
+              <a:t>Currently trying to add </a:t>
             </a:r>
             <a:r>
               <a:rPr lang="en-GB" dirty="0" err="1"/>
-              <a:t>dMRI</a:t>
-            </a:r>
-            <a:r>
-              <a:rPr lang="en-GB" dirty="0"/>
-              <a:t> modalities (need more time for study)</a:t>
+              <a:t>eeg</a:t>
+            </a:r>
+            <a:r>
+              <a:rPr lang="en-GB" dirty="0"/>
+              <a:t>-coherence example to the website</a:t>
             </a:r>
           </a:p>
         </p:txBody>
@@ -6424,7 +6468,13 @@
   <p:cSld>
     <p:spTree>
       <p:nvGrpSpPr>
-        <p:cNvPr id="1" name=""/>
+        <p:cNvPr id="1" name="">
+          <a:extLst>
+            <a:ext uri="{FF2B5EF4-FFF2-40B4-BE49-F238E27FC236}">
+              <a16:creationId xmlns:a16="http://schemas.microsoft.com/office/drawing/2014/main" id="{9D2B78D6-7D31-E86B-FCF8-FCC651C21E5B}"/>
+            </a:ext>
+          </a:extLst>
+        </p:cNvPr>
         <p:cNvGrpSpPr/>
         <p:nvPr/>
       </p:nvGrpSpPr>
@@ -6441,7 +6491,7 @@
           <p:cNvPr id="2" name="Title 1">
             <a:extLst>
               <a:ext uri="{FF2B5EF4-FFF2-40B4-BE49-F238E27FC236}">
-                <a16:creationId xmlns:a16="http://schemas.microsoft.com/office/drawing/2014/main" id="{593C6542-E0B7-C741-85FE-6F66ADF534B4}"/>
+                <a16:creationId xmlns:a16="http://schemas.microsoft.com/office/drawing/2014/main" id="{7AF55F3B-75A5-4D59-8A03-DEFBF1B920D7}"/>
               </a:ext>
             </a:extLst>
           </p:cNvPr>
@@ -6459,7 +6509,7 @@
           <a:p>
             <a:r>
               <a:rPr lang="en-GB" dirty="0"/>
-              <a:t>Searching For Alternative Example</a:t>
+              <a:t>Summary of Previous Meetings</a:t>
             </a:r>
           </a:p>
         </p:txBody>
@@ -6469,7 +6519,7 @@
           <p:cNvPr id="3" name="Content Placeholder 2">
             <a:extLst>
               <a:ext uri="{FF2B5EF4-FFF2-40B4-BE49-F238E27FC236}">
-                <a16:creationId xmlns:a16="http://schemas.microsoft.com/office/drawing/2014/main" id="{77A62677-4C55-29F7-0541-52755F736C4C}"/>
+                <a16:creationId xmlns:a16="http://schemas.microsoft.com/office/drawing/2014/main" id="{D99908CD-DF35-F721-D0EF-B8DC59E8908B}"/>
               </a:ext>
             </a:extLst>
           </p:cNvPr>
@@ -6482,9 +6532,7 @@
         </p:nvSpPr>
         <p:spPr/>
         <p:txBody>
-          <a:bodyPr>
-            <a:normAutofit fontScale="70000" lnSpcReduction="20000"/>
-          </a:bodyPr>
+          <a:bodyPr/>
           <a:lstStyle/>
           <a:p>
             <a:pPr marL="342900" indent="-342900">
@@ -6493,7 +6541,7 @@
             </a:pPr>
             <a:r>
               <a:rPr lang="en-GB" dirty="0"/>
-              <a:t>Instead of MRI, focus on data/output/metrics obtained using electrophysiological neuroimaging methods.</a:t>
+              <a:t>Discussed how fluid could be useful for neuroscience research.</a:t>
             </a:r>
           </a:p>
           <a:p>
@@ -6501,7 +6549,10 @@
               <a:buFont typeface="Arial" panose="020B0604020202020204" pitchFamily="34" charset="0"/>
               <a:buChar char="•"/>
             </a:pPr>
-            <a:endParaRPr lang="en-GB" dirty="0"/>
+            <a:r>
+              <a:rPr lang="en-GB" dirty="0"/>
+              <a:t>Discussed using Fluid to create interactive plots for functional, structural connectivity in human brain.</a:t>
+            </a:r>
           </a:p>
           <a:p>
             <a:pPr marL="342900" indent="-342900">
@@ -6510,7 +6561,17 @@
             </a:pPr>
             <a:r>
               <a:rPr lang="en-GB" dirty="0"/>
-              <a:t>MRI </a:t>
+              <a:t>Using triaxial view of the brain, paired with FC and SC adjacency matrices.</a:t>
+            </a:r>
+          </a:p>
+          <a:p>
+            <a:pPr marL="342900" indent="-342900">
+              <a:buFont typeface="Arial" panose="020B0604020202020204" pitchFamily="34" charset="0"/>
+              <a:buChar char="•"/>
+            </a:pPr>
+            <a:r>
+              <a:rPr lang="en-GB" dirty="0"/>
+              <a:t>Issues with this plan:</a:t>
             </a:r>
           </a:p>
           <a:p>
@@ -6520,7 +6581,7 @@
             </a:pPr>
             <a:r>
               <a:rPr lang="en-GB" dirty="0"/>
-              <a:t>obtain brain activity in terms of oxygen consumption </a:t>
+              <a:t>Triaxial view difficult to incorporate with current fluid structure</a:t>
             </a:r>
           </a:p>
           <a:p>
@@ -6530,7 +6591,7 @@
             </a:pPr>
             <a:r>
               <a:rPr lang="en-GB" dirty="0"/>
-              <a:t>gives structure, function, pathway information</a:t>
+              <a:t>Data provenance not clear for FC and SC values</a:t>
             </a:r>
           </a:p>
           <a:p>
@@ -6540,7 +6601,7 @@
             </a:pPr>
             <a:r>
               <a:rPr lang="en-GB" dirty="0"/>
-              <a:t>Need triaxial, 3D view to display output along with help from brain-atlases</a:t>
+              <a:t>Multidimensional data (if time, tasks conditions included)</a:t>
             </a:r>
           </a:p>
           <a:p>
@@ -6550,132 +6611,23 @@
             </a:pPr>
             <a:r>
               <a:rPr lang="en-GB" dirty="0"/>
-              <a:t>Dense and overlapping outputs</a:t>
-            </a:r>
-          </a:p>
-          <a:p>
-            <a:pPr marL="800100" lvl="1" indent="-342900">
-              <a:buFont typeface="Arial" panose="020B0604020202020204" pitchFamily="34" charset="0"/>
-              <a:buChar char="•"/>
-            </a:pPr>
-            <a:r>
-              <a:rPr lang="en-GB" b="1" dirty="0"/>
-              <a:t>Eventually need to handle this output but difficult to begin with</a:t>
-            </a:r>
-          </a:p>
-          <a:p>
-            <a:pPr marL="342900" indent="-342900">
-              <a:buFont typeface="Arial" panose="020B0604020202020204" pitchFamily="34" charset="0"/>
-              <a:buChar char="•"/>
-            </a:pPr>
-            <a:r>
-              <a:rPr lang="en-GB" dirty="0"/>
-              <a:t>EEG/MEG</a:t>
-            </a:r>
-          </a:p>
-          <a:p>
-            <a:pPr marL="800100" lvl="1" indent="-342900">
-              <a:buFont typeface="Arial" panose="020B0604020202020204" pitchFamily="34" charset="0"/>
-              <a:buChar char="•"/>
-            </a:pPr>
-            <a:r>
-              <a:rPr lang="en-GB" dirty="0"/>
-              <a:t>Obtain brain activity in terms of electromagnetics in the brain</a:t>
-            </a:r>
-          </a:p>
-          <a:p>
-            <a:pPr marL="800100" lvl="1" indent="-342900">
-              <a:buFont typeface="Arial" panose="020B0604020202020204" pitchFamily="34" charset="0"/>
-              <a:buChar char="•"/>
-            </a:pPr>
-            <a:r>
-              <a:rPr lang="en-GB" dirty="0"/>
-              <a:t>Gives function, connectivity, network and temporal information</a:t>
-            </a:r>
-          </a:p>
-          <a:p>
-            <a:pPr marL="800100" lvl="1" indent="-342900">
-              <a:buFont typeface="Arial" panose="020B0604020202020204" pitchFamily="34" charset="0"/>
-              <a:buChar char="•"/>
-            </a:pPr>
-            <a:r>
-              <a:rPr lang="en-GB" dirty="0"/>
-              <a:t>Easy to incorporate with fluid given the outputs are mostly line graphs, topographical plots, matrices</a:t>
-            </a:r>
-          </a:p>
-          <a:p>
-            <a:pPr marL="800100" lvl="1" indent="-342900">
-              <a:buFont typeface="Arial" panose="020B0604020202020204" pitchFamily="34" charset="0"/>
-              <a:buChar char="•"/>
-            </a:pPr>
-            <a:r>
-              <a:rPr lang="en-GB" dirty="0"/>
-              <a:t>Need more functions such as multiple cascading plots/graphs, multi-level selection etc</a:t>
-            </a:r>
-          </a:p>
-          <a:p>
-            <a:pPr marL="342900" indent="-342900">
-              <a:buFont typeface="Arial" panose="020B0604020202020204" pitchFamily="34" charset="0"/>
-              <a:buChar char="•"/>
-            </a:pPr>
-            <a:r>
-              <a:rPr lang="en-GB" dirty="0"/>
-              <a:t>Computational/</a:t>
+              <a:t>Not well-versed with fMRI, </a:t>
             </a:r>
             <a:r>
               <a:rPr lang="en-GB" dirty="0" err="1"/>
-              <a:t>Behavioral</a:t>
-            </a:r>
-            <a:r>
-              <a:rPr lang="en-GB" dirty="0"/>
-              <a:t> methods</a:t>
-            </a:r>
-          </a:p>
-          <a:p>
-            <a:pPr marL="800100" lvl="1" indent="-342900">
-              <a:buFont typeface="Arial" panose="020B0604020202020204" pitchFamily="34" charset="0"/>
-              <a:buChar char="•"/>
-            </a:pPr>
-            <a:r>
-              <a:rPr lang="en-GB" dirty="0"/>
-              <a:t>RT-based studies, Eye-tracking, tapping, motor tests</a:t>
-            </a:r>
-          </a:p>
-          <a:p>
-            <a:pPr marL="342900" indent="-342900">
-              <a:buFont typeface="Arial" panose="020B0604020202020204" pitchFamily="34" charset="0"/>
-              <a:buChar char="•"/>
-            </a:pPr>
-            <a:r>
-              <a:rPr lang="en-GB" dirty="0"/>
-              <a:t>Other neuroimaging methods</a:t>
-            </a:r>
-          </a:p>
-          <a:p>
-            <a:pPr marL="800100" lvl="1" indent="-342900">
-              <a:buFont typeface="Arial" panose="020B0604020202020204" pitchFamily="34" charset="0"/>
-              <a:buChar char="•"/>
-            </a:pPr>
-            <a:r>
-              <a:rPr lang="en-GB" dirty="0" err="1"/>
-              <a:t>fNIRS</a:t>
-            </a:r>
-            <a:r>
-              <a:rPr lang="en-GB" dirty="0"/>
-              <a:t>, TMS, LFP, </a:t>
-            </a:r>
-            <a:r>
-              <a:rPr lang="en-GB" dirty="0" err="1"/>
-              <a:t>ECoG</a:t>
-            </a:r>
-            <a:endParaRPr lang="en-GB" dirty="0"/>
+              <a:t>dMRI</a:t>
+            </a:r>
+            <a:r>
+              <a:rPr lang="en-GB" dirty="0"/>
+              <a:t> modalities (need more time for study)</a:t>
+            </a:r>
           </a:p>
         </p:txBody>
       </p:sp>
     </p:spTree>
     <p:extLst>
       <p:ext uri="{BB962C8B-B14F-4D97-AF65-F5344CB8AC3E}">
-        <p14:creationId xmlns:p14="http://schemas.microsoft.com/office/powerpoint/2010/main" val="1514807859"/>
+        <p14:creationId xmlns:p14="http://schemas.microsoft.com/office/powerpoint/2010/main" val="906623838"/>
       </p:ext>
     </p:extLst>
   </p:cSld>
@@ -6707,6 +6659,272 @@
           <p:cNvPr id="2" name="Title 1">
             <a:extLst>
               <a:ext uri="{FF2B5EF4-FFF2-40B4-BE49-F238E27FC236}">
+                <a16:creationId xmlns:a16="http://schemas.microsoft.com/office/drawing/2014/main" id="{593C6542-E0B7-C741-85FE-6F66ADF534B4}"/>
+              </a:ext>
+            </a:extLst>
+          </p:cNvPr>
+          <p:cNvSpPr>
+            <a:spLocks noGrp="1"/>
+          </p:cNvSpPr>
+          <p:nvPr>
+            <p:ph type="title"/>
+          </p:nvPr>
+        </p:nvSpPr>
+        <p:spPr/>
+        <p:txBody>
+          <a:bodyPr/>
+          <a:lstStyle/>
+          <a:p>
+            <a:r>
+              <a:rPr lang="en-GB" dirty="0"/>
+              <a:t>Searching For Alternative Example</a:t>
+            </a:r>
+          </a:p>
+        </p:txBody>
+      </p:sp>
+      <p:sp>
+        <p:nvSpPr>
+          <p:cNvPr id="3" name="Content Placeholder 2">
+            <a:extLst>
+              <a:ext uri="{FF2B5EF4-FFF2-40B4-BE49-F238E27FC236}">
+                <a16:creationId xmlns:a16="http://schemas.microsoft.com/office/drawing/2014/main" id="{77A62677-4C55-29F7-0541-52755F736C4C}"/>
+              </a:ext>
+            </a:extLst>
+          </p:cNvPr>
+          <p:cNvSpPr>
+            <a:spLocks noGrp="1"/>
+          </p:cNvSpPr>
+          <p:nvPr>
+            <p:ph sz="half" idx="1"/>
+          </p:nvPr>
+        </p:nvSpPr>
+        <p:spPr/>
+        <p:txBody>
+          <a:bodyPr>
+            <a:normAutofit fontScale="70000" lnSpcReduction="20000"/>
+          </a:bodyPr>
+          <a:lstStyle/>
+          <a:p>
+            <a:pPr marL="342900" indent="-342900">
+              <a:buFont typeface="Arial" panose="020B0604020202020204" pitchFamily="34" charset="0"/>
+              <a:buChar char="•"/>
+            </a:pPr>
+            <a:r>
+              <a:rPr lang="en-GB" dirty="0"/>
+              <a:t>Instead of MRI, focus on data/output/metrics obtained using electrophysiological neuroimaging methods.</a:t>
+            </a:r>
+          </a:p>
+          <a:p>
+            <a:pPr marL="342900" indent="-342900">
+              <a:buFont typeface="Arial" panose="020B0604020202020204" pitchFamily="34" charset="0"/>
+              <a:buChar char="•"/>
+            </a:pPr>
+            <a:endParaRPr lang="en-GB" dirty="0"/>
+          </a:p>
+          <a:p>
+            <a:pPr marL="342900" indent="-342900">
+              <a:buFont typeface="Arial" panose="020B0604020202020204" pitchFamily="34" charset="0"/>
+              <a:buChar char="•"/>
+            </a:pPr>
+            <a:r>
+              <a:rPr lang="en-GB" dirty="0"/>
+              <a:t>MRI </a:t>
+            </a:r>
+          </a:p>
+          <a:p>
+            <a:pPr marL="800100" lvl="1" indent="-342900">
+              <a:buFont typeface="Arial" panose="020B0604020202020204" pitchFamily="34" charset="0"/>
+              <a:buChar char="•"/>
+            </a:pPr>
+            <a:r>
+              <a:rPr lang="en-GB" dirty="0"/>
+              <a:t>obtain brain activity in terms of oxygen consumption </a:t>
+            </a:r>
+          </a:p>
+          <a:p>
+            <a:pPr marL="800100" lvl="1" indent="-342900">
+              <a:buFont typeface="Arial" panose="020B0604020202020204" pitchFamily="34" charset="0"/>
+              <a:buChar char="•"/>
+            </a:pPr>
+            <a:r>
+              <a:rPr lang="en-GB" dirty="0"/>
+              <a:t>gives structure, function, pathway information</a:t>
+            </a:r>
+          </a:p>
+          <a:p>
+            <a:pPr marL="800100" lvl="1" indent="-342900">
+              <a:buFont typeface="Arial" panose="020B0604020202020204" pitchFamily="34" charset="0"/>
+              <a:buChar char="•"/>
+            </a:pPr>
+            <a:r>
+              <a:rPr lang="en-GB" dirty="0"/>
+              <a:t>Need triaxial, 3D view to display output along with help from brain-atlases</a:t>
+            </a:r>
+          </a:p>
+          <a:p>
+            <a:pPr marL="800100" lvl="1" indent="-342900">
+              <a:buFont typeface="Arial" panose="020B0604020202020204" pitchFamily="34" charset="0"/>
+              <a:buChar char="•"/>
+            </a:pPr>
+            <a:r>
+              <a:rPr lang="en-GB" dirty="0"/>
+              <a:t>Dense and overlapping outputs</a:t>
+            </a:r>
+          </a:p>
+          <a:p>
+            <a:pPr marL="800100" lvl="1" indent="-342900">
+              <a:buFont typeface="Arial" panose="020B0604020202020204" pitchFamily="34" charset="0"/>
+              <a:buChar char="•"/>
+            </a:pPr>
+            <a:r>
+              <a:rPr lang="en-GB" b="1" dirty="0"/>
+              <a:t>Eventually need to handle this output but difficult to begin with</a:t>
+            </a:r>
+          </a:p>
+          <a:p>
+            <a:pPr marL="342900" indent="-342900">
+              <a:buFont typeface="Arial" panose="020B0604020202020204" pitchFamily="34" charset="0"/>
+              <a:buChar char="•"/>
+            </a:pPr>
+            <a:r>
+              <a:rPr lang="en-GB" dirty="0"/>
+              <a:t>EEG/MEG</a:t>
+            </a:r>
+          </a:p>
+          <a:p>
+            <a:pPr marL="800100" lvl="1" indent="-342900">
+              <a:buFont typeface="Arial" panose="020B0604020202020204" pitchFamily="34" charset="0"/>
+              <a:buChar char="•"/>
+            </a:pPr>
+            <a:r>
+              <a:rPr lang="en-GB" dirty="0"/>
+              <a:t>Obtain brain activity in terms of electromagnetics in the brain</a:t>
+            </a:r>
+          </a:p>
+          <a:p>
+            <a:pPr marL="800100" lvl="1" indent="-342900">
+              <a:buFont typeface="Arial" panose="020B0604020202020204" pitchFamily="34" charset="0"/>
+              <a:buChar char="•"/>
+            </a:pPr>
+            <a:r>
+              <a:rPr lang="en-GB" dirty="0"/>
+              <a:t>Gives function, connectivity, network and temporal information</a:t>
+            </a:r>
+          </a:p>
+          <a:p>
+            <a:pPr marL="800100" lvl="1" indent="-342900">
+              <a:buFont typeface="Arial" panose="020B0604020202020204" pitchFamily="34" charset="0"/>
+              <a:buChar char="•"/>
+            </a:pPr>
+            <a:r>
+              <a:rPr lang="en-GB" dirty="0"/>
+              <a:t>Easy to incorporate with fluid given the outputs are mostly line graphs, topographical plots, matrices</a:t>
+            </a:r>
+          </a:p>
+          <a:p>
+            <a:pPr marL="800100" lvl="1" indent="-342900">
+              <a:buFont typeface="Arial" panose="020B0604020202020204" pitchFamily="34" charset="0"/>
+              <a:buChar char="•"/>
+            </a:pPr>
+            <a:r>
+              <a:rPr lang="en-GB" dirty="0"/>
+              <a:t>Need more functions such as multiple cascading plots/graphs, multi-level selection etc</a:t>
+            </a:r>
+          </a:p>
+          <a:p>
+            <a:pPr marL="342900" indent="-342900">
+              <a:buFont typeface="Arial" panose="020B0604020202020204" pitchFamily="34" charset="0"/>
+              <a:buChar char="•"/>
+            </a:pPr>
+            <a:r>
+              <a:rPr lang="en-GB" dirty="0"/>
+              <a:t>Computational/</a:t>
+            </a:r>
+            <a:r>
+              <a:rPr lang="en-GB" dirty="0" err="1"/>
+              <a:t>Behavioral</a:t>
+            </a:r>
+            <a:r>
+              <a:rPr lang="en-GB" dirty="0"/>
+              <a:t> methods</a:t>
+            </a:r>
+          </a:p>
+          <a:p>
+            <a:pPr marL="800100" lvl="1" indent="-342900">
+              <a:buFont typeface="Arial" panose="020B0604020202020204" pitchFamily="34" charset="0"/>
+              <a:buChar char="•"/>
+            </a:pPr>
+            <a:r>
+              <a:rPr lang="en-GB" dirty="0"/>
+              <a:t>RT-based studies, Eye-tracking, tapping, motor tests</a:t>
+            </a:r>
+          </a:p>
+          <a:p>
+            <a:pPr marL="342900" indent="-342900">
+              <a:buFont typeface="Arial" panose="020B0604020202020204" pitchFamily="34" charset="0"/>
+              <a:buChar char="•"/>
+            </a:pPr>
+            <a:r>
+              <a:rPr lang="en-GB" dirty="0"/>
+              <a:t>Other neuroimaging methods</a:t>
+            </a:r>
+          </a:p>
+          <a:p>
+            <a:pPr marL="800100" lvl="1" indent="-342900">
+              <a:buFont typeface="Arial" panose="020B0604020202020204" pitchFamily="34" charset="0"/>
+              <a:buChar char="•"/>
+            </a:pPr>
+            <a:r>
+              <a:rPr lang="en-GB" dirty="0" err="1"/>
+              <a:t>fNIRS</a:t>
+            </a:r>
+            <a:r>
+              <a:rPr lang="en-GB" dirty="0"/>
+              <a:t>, TMS, LFP, </a:t>
+            </a:r>
+            <a:r>
+              <a:rPr lang="en-GB" dirty="0" err="1"/>
+              <a:t>ECoG</a:t>
+            </a:r>
+            <a:endParaRPr lang="en-GB" dirty="0"/>
+          </a:p>
+        </p:txBody>
+      </p:sp>
+    </p:spTree>
+    <p:extLst>
+      <p:ext uri="{BB962C8B-B14F-4D97-AF65-F5344CB8AC3E}">
+        <p14:creationId xmlns:p14="http://schemas.microsoft.com/office/powerpoint/2010/main" val="1514807859"/>
+      </p:ext>
+    </p:extLst>
+  </p:cSld>
+  <p:clrMapOvr>
+    <a:masterClrMapping/>
+  </p:clrMapOvr>
+</p:sld>
+</file>
+
+<file path=ppt/slides/slide5.xml><?xml version="1.0" encoding="utf-8"?>
+<p:sld xmlns:a="http://schemas.openxmlformats.org/drawingml/2006/main" xmlns:r="http://schemas.openxmlformats.org/officeDocument/2006/relationships" xmlns:p="http://schemas.openxmlformats.org/presentationml/2006/main">
+  <p:cSld>
+    <p:spTree>
+      <p:nvGrpSpPr>
+        <p:cNvPr id="1" name=""/>
+        <p:cNvGrpSpPr/>
+        <p:nvPr/>
+      </p:nvGrpSpPr>
+      <p:grpSpPr>
+        <a:xfrm>
+          <a:off x="0" y="0"/>
+          <a:ext cx="0" cy="0"/>
+          <a:chOff x="0" y="0"/>
+          <a:chExt cx="0" cy="0"/>
+        </a:xfrm>
+      </p:grpSpPr>
+      <p:sp>
+        <p:nvSpPr>
+          <p:cNvPr id="2" name="Title 1">
+            <a:extLst>
+              <a:ext uri="{FF2B5EF4-FFF2-40B4-BE49-F238E27FC236}">
                 <a16:creationId xmlns:a16="http://schemas.microsoft.com/office/drawing/2014/main" id="{C68BBB8E-11C6-E9B9-0EEF-0CD7BA501ABB}"/>
               </a:ext>
             </a:extLst>
@@ -6871,7 +7089,7 @@
 </p:sld>
 </file>
 
-<file path=ppt/slides/slide5.xml><?xml version="1.0" encoding="utf-8"?>
+<file path=ppt/slides/slide6.xml><?xml version="1.0" encoding="utf-8"?>
 <p:sld xmlns:a="http://schemas.openxmlformats.org/drawingml/2006/main" xmlns:r="http://schemas.openxmlformats.org/officeDocument/2006/relationships" xmlns:p="http://schemas.openxmlformats.org/presentationml/2006/main">
   <p:cSld>
     <p:spTree>
@@ -7669,7 +7887,7 @@
 </p:sld>
 </file>
 
-<file path=ppt/slides/slide6.xml><?xml version="1.0" encoding="utf-8"?>
+<file path=ppt/slides/slide7.xml><?xml version="1.0" encoding="utf-8"?>
 <p:sld xmlns:a="http://schemas.openxmlformats.org/drawingml/2006/main" xmlns:r="http://schemas.openxmlformats.org/officeDocument/2006/relationships" xmlns:p="http://schemas.openxmlformats.org/presentationml/2006/main">
   <p:cSld>
     <p:spTree>
@@ -7826,7 +8044,7 @@
 </p:sld>
 </file>
 
-<file path=ppt/slides/slide7.xml><?xml version="1.0" encoding="utf-8"?>
+<file path=ppt/slides/slide8.xml><?xml version="1.0" encoding="utf-8"?>
 <p:sld xmlns:a="http://schemas.openxmlformats.org/drawingml/2006/main" xmlns:r="http://schemas.openxmlformats.org/officeDocument/2006/relationships" xmlns:p="http://schemas.openxmlformats.org/presentationml/2006/main">
   <p:cSld>
     <p:spTree>

</xml_diff>

<commit_message>
Added processing steps for EEG dataset
</commit_message>
<xml_diff>
--- a/doc/fluid_neural_data_example.pptx
+++ b/doc/fluid_neural_data_example.pptx
@@ -6,13 +6,16 @@
   </p:sldMasterIdLst>
   <p:sldIdLst>
     <p:sldId id="256" r:id="rId2"/>
-    <p:sldId id="257" r:id="rId3"/>
-    <p:sldId id="263" r:id="rId4"/>
-    <p:sldId id="258" r:id="rId5"/>
-    <p:sldId id="260" r:id="rId6"/>
-    <p:sldId id="262" r:id="rId7"/>
-    <p:sldId id="259" r:id="rId8"/>
-    <p:sldId id="261" r:id="rId9"/>
+    <p:sldId id="263" r:id="rId3"/>
+    <p:sldId id="258" r:id="rId4"/>
+    <p:sldId id="260" r:id="rId5"/>
+    <p:sldId id="262" r:id="rId6"/>
+    <p:sldId id="259" r:id="rId7"/>
+    <p:sldId id="261" r:id="rId8"/>
+    <p:sldId id="257" r:id="rId9"/>
+    <p:sldId id="264" r:id="rId10"/>
+    <p:sldId id="265" r:id="rId11"/>
+    <p:sldId id="266" r:id="rId12"/>
   </p:sldIdLst>
   <p:sldSz cx="12192000" cy="6858000"/>
   <p:notesSz cx="6858000" cy="9144000"/>
@@ -3042,7 +3045,7 @@
           <a:p>
             <a:fld id="{5F8ED5AD-8E45-404E-BB5C-A54C85B9250C}" type="datetimeFigureOut">
               <a:rPr lang="en-GB" smtClean="0"/>
-              <a:t>10/03/2026</a:t>
+              <a:t>27/05/2026</a:t>
             </a:fld>
             <a:endParaRPr lang="en-GB"/>
           </a:p>
@@ -6252,12 +6255,18 @@
 </p:sld>
 </file>
 
-<file path=ppt/slides/slide2.xml><?xml version="1.0" encoding="utf-8"?>
+<file path=ppt/slides/slide10.xml><?xml version="1.0" encoding="utf-8"?>
 <p:sld xmlns:a="http://schemas.openxmlformats.org/drawingml/2006/main" xmlns:r="http://schemas.openxmlformats.org/officeDocument/2006/relationships" xmlns:p="http://schemas.openxmlformats.org/presentationml/2006/main">
   <p:cSld>
     <p:spTree>
       <p:nvGrpSpPr>
-        <p:cNvPr id="1" name=""/>
+        <p:cNvPr id="1" name="">
+          <a:extLst>
+            <a:ext uri="{FF2B5EF4-FFF2-40B4-BE49-F238E27FC236}">
+              <a16:creationId xmlns:a16="http://schemas.microsoft.com/office/drawing/2014/main" id="{4FC2B274-2F35-D700-75C5-21D6838DA3DE}"/>
+            </a:ext>
+          </a:extLst>
+        </p:cNvPr>
         <p:cNvGrpSpPr/>
         <p:nvPr/>
       </p:nvGrpSpPr>
@@ -6274,7 +6283,7 @@
           <p:cNvPr id="2" name="Title 1">
             <a:extLst>
               <a:ext uri="{FF2B5EF4-FFF2-40B4-BE49-F238E27FC236}">
-                <a16:creationId xmlns:a16="http://schemas.microsoft.com/office/drawing/2014/main" id="{CB686F0F-2558-6CD4-ED34-C2081FF05248}"/>
+                <a16:creationId xmlns:a16="http://schemas.microsoft.com/office/drawing/2014/main" id="{39FF5649-6694-FA65-FCD8-2C24FCF5BDFB}"/>
               </a:ext>
             </a:extLst>
           </p:cNvPr>
@@ -6285,16 +6294,20 @@
             <p:ph type="title"/>
           </p:nvPr>
         </p:nvSpPr>
-        <p:spPr/>
+        <p:spPr>
+          <a:xfrm>
+            <a:off x="502919" y="437430"/>
+            <a:ext cx="11305197" cy="478155"/>
+          </a:xfrm>
+        </p:spPr>
         <p:txBody>
           <a:bodyPr/>
           <a:lstStyle/>
           <a:p>
             <a:r>
-              <a:rPr lang="en-GB"/>
-              <a:t>Progress after 12/01/26</a:t>
-            </a:r>
-            <a:endParaRPr lang="en-GB" dirty="0"/>
+              <a:rPr lang="en-GB" dirty="0"/>
+              <a:t>Input-Output Dataset for EEG-Coherence Example</a:t>
+            </a:r>
           </a:p>
         </p:txBody>
       </p:sp>
@@ -6303,7 +6316,7 @@
           <p:cNvPr id="3" name="Content Placeholder 2">
             <a:extLst>
               <a:ext uri="{FF2B5EF4-FFF2-40B4-BE49-F238E27FC236}">
-                <a16:creationId xmlns:a16="http://schemas.microsoft.com/office/drawing/2014/main" id="{45E231A9-DF66-F654-6D8C-9F7A8D20CDFE}"/>
+                <a16:creationId xmlns:a16="http://schemas.microsoft.com/office/drawing/2014/main" id="{1FA8D1F3-8CAD-43EC-6D67-533A40A2CC2E}"/>
               </a:ext>
             </a:extLst>
           </p:cNvPr>
@@ -6314,138 +6327,778 @@
             <p:ph sz="half" idx="1"/>
           </p:nvPr>
         </p:nvSpPr>
-        <p:spPr/>
+        <p:spPr>
+          <a:xfrm>
+            <a:off x="383471" y="1137646"/>
+            <a:ext cx="6326248" cy="2940084"/>
+          </a:xfrm>
+          <a:solidFill>
+            <a:schemeClr val="bg1"/>
+          </a:solidFill>
+          <a:ln>
+            <a:solidFill>
+              <a:schemeClr val="tx1"/>
+            </a:solidFill>
+          </a:ln>
+        </p:spPr>
         <p:txBody>
-          <a:bodyPr/>
+          <a:bodyPr>
+            <a:normAutofit fontScale="47500" lnSpcReduction="20000"/>
+          </a:bodyPr>
           <a:lstStyle/>
+          <a:p>
+            <a:r>
+              <a:rPr lang="en-IN" dirty="0"/>
+              <a:t>1. </a:t>
+            </a:r>
+            <a:r>
+              <a:rPr lang="en-IN" b="1" dirty="0" err="1"/>
+              <a:t>Epoched</a:t>
+            </a:r>
+            <a:r>
+              <a:rPr lang="en-IN" b="1" dirty="0"/>
+              <a:t> data after pre-processing (</a:t>
+            </a:r>
+            <a:r>
+              <a:rPr lang="en-IN" b="1" dirty="0" err="1"/>
+              <a:t>num_timepoints</a:t>
+            </a:r>
+            <a:r>
+              <a:rPr lang="en-IN" b="1" dirty="0"/>
+              <a:t> x </a:t>
+            </a:r>
+            <a:r>
+              <a:rPr lang="en-IN" b="1" dirty="0" err="1"/>
+              <a:t>num_epochs</a:t>
+            </a:r>
+            <a:r>
+              <a:rPr lang="en-IN" b="1" dirty="0"/>
+              <a:t> x </a:t>
+            </a:r>
+            <a:r>
+              <a:rPr lang="en-IN" b="1" dirty="0" err="1"/>
+              <a:t>num_channels</a:t>
+            </a:r>
+            <a:r>
+              <a:rPr lang="en-IN" b="1" dirty="0"/>
+              <a:t>)</a:t>
+            </a:r>
+          </a:p>
+          <a:p>
+            <a:r>
+              <a:rPr lang="en-IN" dirty="0"/>
+              <a:t>Ex :</a:t>
+            </a:r>
+          </a:p>
+          <a:p>
+            <a:r>
+              <a:rPr lang="en-IN" dirty="0"/>
+              <a:t>{ "timepoint": 0, "epoch": 1, "channel": "ch01", "</a:t>
+            </a:r>
+            <a:r>
+              <a:rPr lang="en-IN" dirty="0" err="1"/>
+              <a:t>raw_value</a:t>
+            </a:r>
+            <a:r>
+              <a:rPr lang="en-IN" dirty="0"/>
+              <a:t>": 0.251 },</a:t>
+            </a:r>
+          </a:p>
+          <a:p>
+            <a:r>
+              <a:rPr lang="en-IN" dirty="0"/>
+              <a:t>{ "timepoint": 0, "epoch": 1, "channel": "ch02", "</a:t>
+            </a:r>
+            <a:r>
+              <a:rPr lang="en-IN" dirty="0" err="1"/>
+              <a:t>raw_value</a:t>
+            </a:r>
+            <a:r>
+              <a:rPr lang="en-IN" dirty="0"/>
+              <a:t>": 0.251 },</a:t>
+            </a:r>
+          </a:p>
+          <a:p>
+            <a:r>
+              <a:rPr lang="en-IN" dirty="0"/>
+              <a:t>{ "timepoint": 0, "epoch": 1, "channel": "ch03", "</a:t>
+            </a:r>
+            <a:r>
+              <a:rPr lang="en-IN" dirty="0" err="1"/>
+              <a:t>raw_value</a:t>
+            </a:r>
+            <a:r>
+              <a:rPr lang="en-IN" dirty="0"/>
+              <a:t>": 0.251 },</a:t>
+            </a:r>
+          </a:p>
+          <a:p>
+            <a:r>
+              <a:rPr lang="en-IN" dirty="0"/>
+              <a:t>.</a:t>
+            </a:r>
+          </a:p>
+          <a:p>
+            <a:r>
+              <a:rPr lang="en-IN" dirty="0"/>
+              <a:t>{ "timepoint": 0, "epoch": 2, "channel": "ch01", "</a:t>
+            </a:r>
+            <a:r>
+              <a:rPr lang="en-IN" dirty="0" err="1"/>
+              <a:t>raw_value</a:t>
+            </a:r>
+            <a:r>
+              <a:rPr lang="en-IN" dirty="0"/>
+              <a:t>": 0.251 },</a:t>
+            </a:r>
+          </a:p>
+          <a:p>
+            <a:r>
+              <a:rPr lang="en-IN" dirty="0"/>
+              <a:t>{ "timepoint": 0, "epoch": 2, "channel": "ch02", "</a:t>
+            </a:r>
+            <a:r>
+              <a:rPr lang="en-IN" dirty="0" err="1"/>
+              <a:t>raw_value</a:t>
+            </a:r>
+            <a:r>
+              <a:rPr lang="en-IN" dirty="0"/>
+              <a:t>": 0.251 },</a:t>
+            </a:r>
+          </a:p>
+          <a:p>
+            <a:r>
+              <a:rPr lang="en-IN" dirty="0"/>
+              <a:t>.</a:t>
+            </a:r>
+          </a:p>
+          <a:p>
+            <a:r>
+              <a:rPr lang="en-IN" dirty="0"/>
+              <a:t>{ "timepoint": 1, "epoch": 1, "channel": "ch01", "</a:t>
+            </a:r>
+            <a:r>
+              <a:rPr lang="en-IN" dirty="0" err="1"/>
+              <a:t>raw_value</a:t>
+            </a:r>
+            <a:r>
+              <a:rPr lang="en-IN" dirty="0"/>
+              <a:t>": 0.251 },</a:t>
+            </a:r>
+          </a:p>
+          <a:p>
+            <a:r>
+              <a:rPr lang="en-IN" dirty="0"/>
+              <a:t>{ "timepoint": 1, "epoch": 1, "channel": "ch02", "</a:t>
+            </a:r>
+            <a:r>
+              <a:rPr lang="en-IN" dirty="0" err="1"/>
+              <a:t>raw_value</a:t>
+            </a:r>
+            <a:r>
+              <a:rPr lang="en-IN" dirty="0"/>
+              <a:t>": 0.251 },</a:t>
+            </a:r>
+            <a:endParaRPr lang="en-GB" dirty="0"/>
+          </a:p>
+        </p:txBody>
+      </p:sp>
+      <p:sp>
+        <p:nvSpPr>
+          <p:cNvPr id="4" name="Content Placeholder 2">
+            <a:extLst>
+              <a:ext uri="{FF2B5EF4-FFF2-40B4-BE49-F238E27FC236}">
+                <a16:creationId xmlns:a16="http://schemas.microsoft.com/office/drawing/2014/main" id="{9355D74A-B1EF-BFBC-1C6B-17BF2CFCD214}"/>
+              </a:ext>
+            </a:extLst>
+          </p:cNvPr>
+          <p:cNvSpPr txBox="1">
+            <a:spLocks/>
+          </p:cNvSpPr>
+          <p:nvPr/>
+        </p:nvSpPr>
+        <p:spPr>
+          <a:xfrm>
+            <a:off x="4843849" y="3500121"/>
+            <a:ext cx="7100193" cy="3147129"/>
+          </a:xfrm>
+          <a:prstGeom prst="rect">
+            <a:avLst/>
+          </a:prstGeom>
+          <a:solidFill>
+            <a:schemeClr val="bg1"/>
+          </a:solidFill>
+          <a:ln>
+            <a:solidFill>
+              <a:schemeClr val="tx1"/>
+            </a:solidFill>
+          </a:ln>
+        </p:spPr>
+        <p:txBody>
+          <a:bodyPr vert="horz" lIns="91440" tIns="45720" rIns="91440" bIns="45720" rtlCol="0">
+            <a:normAutofit/>
+          </a:bodyPr>
+          <a:lstStyle>
+            <a:lvl1pPr marL="0" indent="0" algn="l" defTabSz="914400" rtl="0" eaLnBrk="1" latinLnBrk="0" hangingPunct="1">
+              <a:lnSpc>
+                <a:spcPct val="90000"/>
+              </a:lnSpc>
+              <a:spcBef>
+                <a:spcPts val="1000"/>
+              </a:spcBef>
+              <a:buFont typeface="Arial" panose="020B0604020202020204" pitchFamily="34" charset="0"/>
+              <a:buNone/>
+              <a:defRPr sz="2400" kern="1200">
+                <a:solidFill>
+                  <a:srgbClr val="1B1B1B"/>
+                </a:solidFill>
+                <a:latin typeface="Arial" panose="020B0604020202020204" pitchFamily="34" charset="0"/>
+                <a:ea typeface="+mn-ea"/>
+                <a:cs typeface="Arial" panose="020B0604020202020204" pitchFamily="34" charset="0"/>
+              </a:defRPr>
+            </a:lvl1pPr>
+            <a:lvl2pPr marL="457200" indent="0" algn="l" defTabSz="914400" rtl="0" eaLnBrk="1" latinLnBrk="0" hangingPunct="1">
+              <a:lnSpc>
+                <a:spcPct val="90000"/>
+              </a:lnSpc>
+              <a:spcBef>
+                <a:spcPts val="500"/>
+              </a:spcBef>
+              <a:buFont typeface="Arial" panose="020B0604020202020204" pitchFamily="34" charset="0"/>
+              <a:buNone/>
+              <a:defRPr sz="2000" kern="1200">
+                <a:solidFill>
+                  <a:srgbClr val="1B1B1B"/>
+                </a:solidFill>
+                <a:latin typeface="Arial" panose="020B0604020202020204" pitchFamily="34" charset="0"/>
+                <a:ea typeface="+mn-ea"/>
+                <a:cs typeface="Arial" panose="020B0604020202020204" pitchFamily="34" charset="0"/>
+              </a:defRPr>
+            </a:lvl2pPr>
+            <a:lvl3pPr marL="914400" indent="0" algn="l" defTabSz="914400" rtl="0" eaLnBrk="1" latinLnBrk="0" hangingPunct="1">
+              <a:lnSpc>
+                <a:spcPct val="90000"/>
+              </a:lnSpc>
+              <a:spcBef>
+                <a:spcPts val="500"/>
+              </a:spcBef>
+              <a:buFont typeface="Arial" panose="020B0604020202020204" pitchFamily="34" charset="0"/>
+              <a:buNone/>
+              <a:defRPr sz="1800" kern="1200">
+                <a:solidFill>
+                  <a:srgbClr val="1B1B1B"/>
+                </a:solidFill>
+                <a:latin typeface="Arial" panose="020B0604020202020204" pitchFamily="34" charset="0"/>
+                <a:ea typeface="+mn-ea"/>
+                <a:cs typeface="Arial" panose="020B0604020202020204" pitchFamily="34" charset="0"/>
+              </a:defRPr>
+            </a:lvl3pPr>
+            <a:lvl4pPr marL="1371600" indent="0" algn="l" defTabSz="914400" rtl="0" eaLnBrk="1" latinLnBrk="0" hangingPunct="1">
+              <a:lnSpc>
+                <a:spcPct val="90000"/>
+              </a:lnSpc>
+              <a:spcBef>
+                <a:spcPts val="500"/>
+              </a:spcBef>
+              <a:buFont typeface="Arial" panose="020B0604020202020204" pitchFamily="34" charset="0"/>
+              <a:buNone/>
+              <a:defRPr sz="1600" kern="1200">
+                <a:solidFill>
+                  <a:srgbClr val="1B1B1B"/>
+                </a:solidFill>
+                <a:latin typeface="Arial" panose="020B0604020202020204" pitchFamily="34" charset="0"/>
+                <a:ea typeface="+mn-ea"/>
+                <a:cs typeface="Arial" panose="020B0604020202020204" pitchFamily="34" charset="0"/>
+              </a:defRPr>
+            </a:lvl4pPr>
+            <a:lvl5pPr marL="1828800" indent="0" algn="l" defTabSz="914400" rtl="0" eaLnBrk="1" latinLnBrk="0" hangingPunct="1">
+              <a:lnSpc>
+                <a:spcPct val="90000"/>
+              </a:lnSpc>
+              <a:spcBef>
+                <a:spcPts val="500"/>
+              </a:spcBef>
+              <a:buFont typeface="Arial" panose="020B0604020202020204" pitchFamily="34" charset="0"/>
+              <a:buNone/>
+              <a:defRPr sz="1600" kern="1200">
+                <a:solidFill>
+                  <a:srgbClr val="1B1B1B"/>
+                </a:solidFill>
+                <a:latin typeface="Arial" panose="020B0604020202020204" pitchFamily="34" charset="0"/>
+                <a:ea typeface="+mn-ea"/>
+                <a:cs typeface="Arial" panose="020B0604020202020204" pitchFamily="34" charset="0"/>
+              </a:defRPr>
+            </a:lvl5pPr>
+            <a:lvl6pPr marL="2514600" indent="-228600" algn="l" defTabSz="914400" rtl="0" eaLnBrk="1" latinLnBrk="0" hangingPunct="1">
+              <a:lnSpc>
+                <a:spcPct val="90000"/>
+              </a:lnSpc>
+              <a:spcBef>
+                <a:spcPts val="500"/>
+              </a:spcBef>
+              <a:buFont typeface="Arial" panose="020B0604020202020204" pitchFamily="34" charset="0"/>
+              <a:buChar char="•"/>
+              <a:defRPr sz="1800" kern="1200">
+                <a:solidFill>
+                  <a:schemeClr val="tx1"/>
+                </a:solidFill>
+                <a:latin typeface="+mn-lt"/>
+                <a:ea typeface="+mn-ea"/>
+                <a:cs typeface="+mn-cs"/>
+              </a:defRPr>
+            </a:lvl6pPr>
+            <a:lvl7pPr marL="2971800" indent="-228600" algn="l" defTabSz="914400" rtl="0" eaLnBrk="1" latinLnBrk="0" hangingPunct="1">
+              <a:lnSpc>
+                <a:spcPct val="90000"/>
+              </a:lnSpc>
+              <a:spcBef>
+                <a:spcPts val="500"/>
+              </a:spcBef>
+              <a:buFont typeface="Arial" panose="020B0604020202020204" pitchFamily="34" charset="0"/>
+              <a:buChar char="•"/>
+              <a:defRPr sz="1800" kern="1200">
+                <a:solidFill>
+                  <a:schemeClr val="tx1"/>
+                </a:solidFill>
+                <a:latin typeface="+mn-lt"/>
+                <a:ea typeface="+mn-ea"/>
+                <a:cs typeface="+mn-cs"/>
+              </a:defRPr>
+            </a:lvl7pPr>
+            <a:lvl8pPr marL="3429000" indent="-228600" algn="l" defTabSz="914400" rtl="0" eaLnBrk="1" latinLnBrk="0" hangingPunct="1">
+              <a:lnSpc>
+                <a:spcPct val="90000"/>
+              </a:lnSpc>
+              <a:spcBef>
+                <a:spcPts val="500"/>
+              </a:spcBef>
+              <a:buFont typeface="Arial" panose="020B0604020202020204" pitchFamily="34" charset="0"/>
+              <a:buChar char="•"/>
+              <a:defRPr sz="1800" kern="1200">
+                <a:solidFill>
+                  <a:schemeClr val="tx1"/>
+                </a:solidFill>
+                <a:latin typeface="+mn-lt"/>
+                <a:ea typeface="+mn-ea"/>
+                <a:cs typeface="+mn-cs"/>
+              </a:defRPr>
+            </a:lvl8pPr>
+            <a:lvl9pPr marL="3886200" indent="-228600" algn="l" defTabSz="914400" rtl="0" eaLnBrk="1" latinLnBrk="0" hangingPunct="1">
+              <a:lnSpc>
+                <a:spcPct val="90000"/>
+              </a:lnSpc>
+              <a:spcBef>
+                <a:spcPts val="500"/>
+              </a:spcBef>
+              <a:buFont typeface="Arial" panose="020B0604020202020204" pitchFamily="34" charset="0"/>
+              <a:buChar char="•"/>
+              <a:defRPr sz="1800" kern="1200">
+                <a:solidFill>
+                  <a:schemeClr val="tx1"/>
+                </a:solidFill>
+                <a:latin typeface="+mn-lt"/>
+                <a:ea typeface="+mn-ea"/>
+                <a:cs typeface="+mn-cs"/>
+              </a:defRPr>
+            </a:lvl9pPr>
+          </a:lstStyle>
+          <a:p>
+            <a:r>
+              <a:rPr lang="en-IN" sz="1100" dirty="0"/>
+              <a:t>2. </a:t>
+            </a:r>
+            <a:r>
+              <a:rPr lang="en-IN" sz="1100" b="1" dirty="0"/>
+              <a:t>Functional Connectivity after processing </a:t>
+            </a:r>
+            <a:r>
+              <a:rPr lang="en-IN" sz="1100" b="1" dirty="0" err="1"/>
+              <a:t>epoched</a:t>
+            </a:r>
+            <a:r>
+              <a:rPr lang="en-IN" sz="1100" b="1" dirty="0"/>
+              <a:t> data (</a:t>
+            </a:r>
+            <a:r>
+              <a:rPr lang="en-IN" sz="1100" b="1" dirty="0" err="1"/>
+              <a:t>num_timepoints</a:t>
+            </a:r>
+            <a:r>
+              <a:rPr lang="en-IN" sz="1100" b="1" dirty="0"/>
+              <a:t> x </a:t>
+            </a:r>
+            <a:r>
+              <a:rPr lang="en-IN" sz="1100" b="1" dirty="0" err="1"/>
+              <a:t>conn_level</a:t>
+            </a:r>
+            <a:r>
+              <a:rPr lang="en-IN" sz="1100" b="1" dirty="0"/>
+              <a:t> x </a:t>
+            </a:r>
+            <a:r>
+              <a:rPr lang="en-IN" sz="1100" b="1" dirty="0" err="1"/>
+              <a:t>conn_metric</a:t>
+            </a:r>
+            <a:r>
+              <a:rPr lang="en-IN" sz="1100" b="1" dirty="0"/>
+              <a:t>)</a:t>
+            </a:r>
+          </a:p>
+          <a:p>
+            <a:r>
+              <a:rPr lang="en-IN" sz="1100" dirty="0"/>
+              <a:t>Ex : </a:t>
+            </a:r>
+          </a:p>
+          <a:p>
+            <a:r>
+              <a:rPr lang="en-IN" sz="1100" dirty="0"/>
+              <a:t>{ "timepoint": 0, "</a:t>
+            </a:r>
+            <a:r>
+              <a:rPr lang="en-IN" sz="1100" dirty="0" err="1"/>
+              <a:t>conn_level</a:t>
+            </a:r>
+            <a:r>
+              <a:rPr lang="en-IN" sz="1100" dirty="0"/>
+              <a:t>": "level1", "</a:t>
+            </a:r>
+            <a:r>
+              <a:rPr lang="en-IN" sz="1100" dirty="0" err="1"/>
+              <a:t>conn_metric</a:t>
+            </a:r>
+            <a:r>
+              <a:rPr lang="en-IN" sz="1100" dirty="0"/>
+              <a:t>": "coherence", "</a:t>
+            </a:r>
+            <a:r>
+              <a:rPr lang="en-IN" sz="1100" dirty="0" err="1"/>
+              <a:t>conn_value</a:t>
+            </a:r>
+            <a:r>
+              <a:rPr lang="en-IN" sz="1100" dirty="0"/>
+              <a:t>": 0.251 },</a:t>
+            </a:r>
+          </a:p>
+          <a:p>
+            <a:r>
+              <a:rPr lang="en-IN" sz="1100" dirty="0"/>
+              <a:t>{ "timepoint": 0, "</a:t>
+            </a:r>
+            <a:r>
+              <a:rPr lang="en-IN" sz="1100" dirty="0" err="1"/>
+              <a:t>conn_level</a:t>
+            </a:r>
+            <a:r>
+              <a:rPr lang="en-IN" sz="1100" dirty="0"/>
+              <a:t>": "level1", "</a:t>
+            </a:r>
+            <a:r>
+              <a:rPr lang="en-IN" sz="1100" dirty="0" err="1"/>
+              <a:t>conn_metric</a:t>
+            </a:r>
+            <a:r>
+              <a:rPr lang="en-IN" sz="1100" dirty="0"/>
+              <a:t>": "wPLI", "</a:t>
+            </a:r>
+            <a:r>
+              <a:rPr lang="en-IN" sz="1100" dirty="0" err="1"/>
+              <a:t>conn_value</a:t>
+            </a:r>
+            <a:r>
+              <a:rPr lang="en-IN" sz="1100" dirty="0"/>
+              <a:t>": 0.255 },</a:t>
+            </a:r>
+          </a:p>
+          <a:p>
+            <a:r>
+              <a:rPr lang="en-IN" sz="1100" dirty="0"/>
+              <a:t>{ "timepoint": 0, "</a:t>
+            </a:r>
+            <a:r>
+              <a:rPr lang="en-IN" sz="1100" dirty="0" err="1"/>
+              <a:t>conn_level</a:t>
+            </a:r>
+            <a:r>
+              <a:rPr lang="en-IN" sz="1100" dirty="0"/>
+              <a:t>": "level2", "</a:t>
+            </a:r>
+            <a:r>
+              <a:rPr lang="en-IN" sz="1100" dirty="0" err="1"/>
+              <a:t>conn_metric</a:t>
+            </a:r>
+            <a:r>
+              <a:rPr lang="en-IN" sz="1100" dirty="0"/>
+              <a:t>": "coherence", "</a:t>
+            </a:r>
+            <a:r>
+              <a:rPr lang="en-IN" sz="1100" dirty="0" err="1"/>
+              <a:t>conn_value</a:t>
+            </a:r>
+            <a:r>
+              <a:rPr lang="en-IN" sz="1100" dirty="0"/>
+              <a:t>": 0.251 },</a:t>
+            </a:r>
+          </a:p>
+          <a:p>
+            <a:r>
+              <a:rPr lang="en-IN" sz="1100" dirty="0"/>
+              <a:t>{ "timepoint": 0, "</a:t>
+            </a:r>
+            <a:r>
+              <a:rPr lang="en-IN" sz="1100" dirty="0" err="1"/>
+              <a:t>conn_level</a:t>
+            </a:r>
+            <a:r>
+              <a:rPr lang="en-IN" sz="1100" dirty="0"/>
+              <a:t>": "level2", "</a:t>
+            </a:r>
+            <a:r>
+              <a:rPr lang="en-IN" sz="1100" dirty="0" err="1"/>
+              <a:t>conn_metric</a:t>
+            </a:r>
+            <a:r>
+              <a:rPr lang="en-IN" sz="1100" dirty="0"/>
+              <a:t>": "wPLI", "</a:t>
+            </a:r>
+            <a:r>
+              <a:rPr lang="en-IN" sz="1100" dirty="0" err="1"/>
+              <a:t>conn_value</a:t>
+            </a:r>
+            <a:r>
+              <a:rPr lang="en-IN" sz="1100" dirty="0"/>
+              <a:t>": 0.255 },</a:t>
+            </a:r>
+          </a:p>
+          <a:p>
+            <a:r>
+              <a:rPr lang="en-IN" sz="1100" dirty="0"/>
+              <a:t>.</a:t>
+            </a:r>
+          </a:p>
+          <a:p>
+            <a:r>
+              <a:rPr lang="en-IN" sz="1100" dirty="0"/>
+              <a:t>{ "timepoint": 1, "</a:t>
+            </a:r>
+            <a:r>
+              <a:rPr lang="en-IN" sz="1100" dirty="0" err="1"/>
+              <a:t>conn_level</a:t>
+            </a:r>
+            <a:r>
+              <a:rPr lang="en-IN" sz="1100" dirty="0"/>
+              <a:t>": "level1", "</a:t>
+            </a:r>
+            <a:r>
+              <a:rPr lang="en-IN" sz="1100" dirty="0" err="1"/>
+              <a:t>conn_metric</a:t>
+            </a:r>
+            <a:r>
+              <a:rPr lang="en-IN" sz="1100" dirty="0"/>
+              <a:t>": "coherence", "</a:t>
+            </a:r>
+            <a:r>
+              <a:rPr lang="en-IN" sz="1100" dirty="0" err="1"/>
+              <a:t>conn_value</a:t>
+            </a:r>
+            <a:r>
+              <a:rPr lang="en-IN" sz="1100" dirty="0"/>
+              <a:t>": 0.251 },</a:t>
+            </a:r>
+          </a:p>
+          <a:p>
+            <a:r>
+              <a:rPr lang="en-IN" sz="1100" dirty="0"/>
+              <a:t>{ "timepoint": 1, "</a:t>
+            </a:r>
+            <a:r>
+              <a:rPr lang="en-IN" sz="1100" dirty="0" err="1"/>
+              <a:t>conn_level</a:t>
+            </a:r>
+            <a:r>
+              <a:rPr lang="en-IN" sz="1100" dirty="0"/>
+              <a:t>": "level1", "</a:t>
+            </a:r>
+            <a:r>
+              <a:rPr lang="en-IN" sz="1100" dirty="0" err="1"/>
+              <a:t>conn_metric</a:t>
+            </a:r>
+            <a:r>
+              <a:rPr lang="en-IN" sz="1100" dirty="0"/>
+              <a:t>": "wPLI", "</a:t>
+            </a:r>
+            <a:r>
+              <a:rPr lang="en-IN" sz="1100" dirty="0" err="1"/>
+              <a:t>conn_value</a:t>
+            </a:r>
+            <a:r>
+              <a:rPr lang="en-IN" sz="1100" dirty="0"/>
+              <a:t>": 0.255 },</a:t>
+            </a:r>
+          </a:p>
+          <a:p>
+            <a:r>
+              <a:rPr lang="en-IN" sz="1100" dirty="0"/>
+              <a:t>{ "timepoint": 1, "</a:t>
+            </a:r>
+            <a:r>
+              <a:rPr lang="en-IN" sz="1100" dirty="0" err="1"/>
+              <a:t>conn_level</a:t>
+            </a:r>
+            <a:r>
+              <a:rPr lang="en-IN" sz="1100" dirty="0"/>
+              <a:t>": "level2", "</a:t>
+            </a:r>
+            <a:r>
+              <a:rPr lang="en-IN" sz="1100" dirty="0" err="1"/>
+              <a:t>conn_metric</a:t>
+            </a:r>
+            <a:r>
+              <a:rPr lang="en-IN" sz="1100" dirty="0"/>
+              <a:t>": "coherence", "</a:t>
+            </a:r>
+            <a:r>
+              <a:rPr lang="en-IN" sz="1100" dirty="0" err="1"/>
+              <a:t>conn_value</a:t>
+            </a:r>
+            <a:r>
+              <a:rPr lang="en-IN" sz="1100" dirty="0"/>
+              <a:t>": 0.251 },</a:t>
+            </a:r>
+          </a:p>
+          <a:p>
+            <a:r>
+              <a:rPr lang="en-IN" sz="1100" dirty="0"/>
+              <a:t>{ "timepoint": 1, "</a:t>
+            </a:r>
+            <a:r>
+              <a:rPr lang="en-IN" sz="1100" dirty="0" err="1"/>
+              <a:t>conn_level</a:t>
+            </a:r>
+            <a:r>
+              <a:rPr lang="en-IN" sz="1100" dirty="0"/>
+              <a:t>": "level2", "</a:t>
+            </a:r>
+            <a:r>
+              <a:rPr lang="en-IN" sz="1100" dirty="0" err="1"/>
+              <a:t>conn_metric</a:t>
+            </a:r>
+            <a:r>
+              <a:rPr lang="en-IN" sz="1100" dirty="0"/>
+              <a:t>": "wPLI", "</a:t>
+            </a:r>
+            <a:r>
+              <a:rPr lang="en-IN" sz="1100" dirty="0" err="1"/>
+              <a:t>conn_value</a:t>
+            </a:r>
+            <a:r>
+              <a:rPr lang="en-IN" sz="1100" dirty="0"/>
+              <a:t>": 0.255 },</a:t>
+            </a:r>
+          </a:p>
           <a:p>
             <a:pPr marL="342900" indent="-342900">
               <a:buFont typeface="Arial" panose="020B0604020202020204" pitchFamily="34" charset="0"/>
               <a:buChar char="•"/>
             </a:pPr>
-            <a:r>
-              <a:rPr lang="en-GB" dirty="0"/>
-              <a:t>Decided to use my MSc thesis output as the base for simulation</a:t>
-            </a:r>
-          </a:p>
-          <a:p>
-            <a:pPr marL="800100" lvl="1" indent="-342900">
-              <a:buFont typeface="Arial" panose="020B0604020202020204" pitchFamily="34" charset="0"/>
-              <a:buChar char="•"/>
-            </a:pPr>
-            <a:r>
-              <a:rPr lang="en-GB" dirty="0"/>
-              <a:t>Not discussed the idea with my supervisor yet</a:t>
-            </a:r>
-          </a:p>
-          <a:p>
-            <a:pPr marL="800100" lvl="1" indent="-342900">
-              <a:buFont typeface="Arial" panose="020B0604020202020204" pitchFamily="34" charset="0"/>
-              <a:buChar char="•"/>
-            </a:pPr>
-            <a:endParaRPr lang="en-GB" dirty="0"/>
-          </a:p>
-          <a:p>
-            <a:pPr marL="342900" indent="-342900">
-              <a:buFont typeface="Arial" panose="020B0604020202020204" pitchFamily="34" charset="0"/>
-              <a:buChar char="•"/>
-            </a:pPr>
-            <a:r>
-              <a:rPr lang="en-GB" dirty="0"/>
-              <a:t>Setting up of repository</a:t>
-            </a:r>
-          </a:p>
-          <a:p>
-            <a:pPr marL="800100" lvl="1" indent="-342900">
-              <a:buFont typeface="Arial" panose="020B0604020202020204" pitchFamily="34" charset="0"/>
-              <a:buChar char="•"/>
-            </a:pPr>
-            <a:r>
-              <a:rPr lang="en-GB" dirty="0"/>
-              <a:t>Created </a:t>
-            </a:r>
-            <a:r>
-              <a:rPr lang="en-GB" dirty="0" err="1"/>
-              <a:t>github</a:t>
-            </a:r>
-            <a:r>
-              <a:rPr lang="en-GB" dirty="0"/>
-              <a:t> organization, to host all relevant repositories</a:t>
-            </a:r>
-          </a:p>
-          <a:p>
-            <a:pPr marL="800100" lvl="1" indent="-342900">
-              <a:buFont typeface="Arial" panose="020B0604020202020204" pitchFamily="34" charset="0"/>
-              <a:buChar char="•"/>
-            </a:pPr>
-            <a:r>
-              <a:rPr lang="en-GB" dirty="0"/>
-              <a:t>Admin access to Roly</a:t>
-            </a:r>
-          </a:p>
-          <a:p>
-            <a:pPr marL="800100" lvl="1" indent="-342900">
-              <a:buFont typeface="Arial" panose="020B0604020202020204" pitchFamily="34" charset="0"/>
-              <a:buChar char="•"/>
-            </a:pPr>
-            <a:r>
-              <a:rPr lang="en-GB" dirty="0"/>
-              <a:t>Example website added</a:t>
-            </a:r>
-          </a:p>
-          <a:p>
-            <a:pPr marL="800100" lvl="1" indent="-342900">
-              <a:buFont typeface="Arial" panose="020B0604020202020204" pitchFamily="34" charset="0"/>
-              <a:buChar char="•"/>
-            </a:pPr>
-            <a:r>
-              <a:rPr lang="en-GB" dirty="0"/>
-              <a:t>Local building and testing of website done</a:t>
-            </a:r>
-          </a:p>
-          <a:p>
-            <a:pPr marL="800100" lvl="1" indent="-342900">
-              <a:buFont typeface="Arial" panose="020B0604020202020204" pitchFamily="34" charset="0"/>
-              <a:buChar char="•"/>
-            </a:pPr>
-            <a:endParaRPr lang="en-GB" dirty="0"/>
-          </a:p>
-          <a:p>
-            <a:pPr marL="342900" indent="-342900">
-              <a:buFont typeface="Arial" panose="020B0604020202020204" pitchFamily="34" charset="0"/>
-              <a:buChar char="•"/>
-            </a:pPr>
-            <a:r>
-              <a:rPr lang="en-GB" dirty="0"/>
-              <a:t>Keeping it simple in the beginning</a:t>
-            </a:r>
-          </a:p>
-          <a:p>
-            <a:pPr marL="800100" lvl="1" indent="-342900">
-              <a:buFont typeface="Arial" panose="020B0604020202020204" pitchFamily="34" charset="0"/>
-              <a:buChar char="•"/>
-            </a:pPr>
-            <a:r>
-              <a:rPr lang="en-GB" dirty="0"/>
-              <a:t>Using only EEG/functional connectivity data to visualize.</a:t>
-            </a:r>
-          </a:p>
-          <a:p>
-            <a:pPr marL="800100" lvl="1" indent="-342900">
-              <a:buFont typeface="Arial" panose="020B0604020202020204" pitchFamily="34" charset="0"/>
-              <a:buChar char="•"/>
-            </a:pPr>
-            <a:r>
-              <a:rPr lang="en-GB" dirty="0"/>
-              <a:t>Currently trying to add </a:t>
-            </a:r>
-            <a:r>
-              <a:rPr lang="en-GB" dirty="0" err="1"/>
-              <a:t>eeg</a:t>
-            </a:r>
-            <a:r>
-              <a:rPr lang="en-GB" dirty="0"/>
-              <a:t>-coherence example to the website</a:t>
+            <a:endParaRPr lang="en-GB" sz="1100" dirty="0"/>
+          </a:p>
+        </p:txBody>
+      </p:sp>
+      <p:sp>
+        <p:nvSpPr>
+          <p:cNvPr id="5" name="Rectangle 4">
+            <a:extLst>
+              <a:ext uri="{FF2B5EF4-FFF2-40B4-BE49-F238E27FC236}">
+                <a16:creationId xmlns:a16="http://schemas.microsoft.com/office/drawing/2014/main" id="{F0C2D66A-2316-8B4E-66B0-E408A6B57037}"/>
+              </a:ext>
+            </a:extLst>
+          </p:cNvPr>
+          <p:cNvSpPr/>
+          <p:nvPr/>
+        </p:nvSpPr>
+        <p:spPr>
+          <a:xfrm>
+            <a:off x="5276335" y="1964724"/>
+            <a:ext cx="914400" cy="914400"/>
+          </a:xfrm>
+          <a:prstGeom prst="rect">
+            <a:avLst/>
+          </a:prstGeom>
+        </p:spPr>
+        <p:style>
+          <a:lnRef idx="2">
+            <a:schemeClr val="accent1">
+              <a:shade val="15000"/>
+            </a:schemeClr>
+          </a:lnRef>
+          <a:fillRef idx="1">
+            <a:schemeClr val="accent1"/>
+          </a:fillRef>
+          <a:effectRef idx="0">
+            <a:schemeClr val="accent1"/>
+          </a:effectRef>
+          <a:fontRef idx="minor">
+            <a:schemeClr val="lt1"/>
+          </a:fontRef>
+        </p:style>
+        <p:txBody>
+          <a:bodyPr rtlCol="0" anchor="ctr"/>
+          <a:lstStyle/>
+          <a:p>
+            <a:pPr algn="ctr"/>
+            <a:r>
+              <a:rPr lang="en-US" dirty="0"/>
+              <a:t>INPUT Dataset</a:t>
+            </a:r>
+          </a:p>
+        </p:txBody>
+      </p:sp>
+      <p:sp>
+        <p:nvSpPr>
+          <p:cNvPr id="6" name="Rectangle 5">
+            <a:extLst>
+              <a:ext uri="{FF2B5EF4-FFF2-40B4-BE49-F238E27FC236}">
+                <a16:creationId xmlns:a16="http://schemas.microsoft.com/office/drawing/2014/main" id="{D31B029D-F35B-8F07-62B5-41C378D0A084}"/>
+              </a:ext>
+            </a:extLst>
+          </p:cNvPr>
+          <p:cNvSpPr/>
+          <p:nvPr/>
+        </p:nvSpPr>
+        <p:spPr>
+          <a:xfrm>
+            <a:off x="10836876" y="5584569"/>
+            <a:ext cx="971241" cy="914400"/>
+          </a:xfrm>
+          <a:prstGeom prst="rect">
+            <a:avLst/>
+          </a:prstGeom>
+        </p:spPr>
+        <p:style>
+          <a:lnRef idx="2">
+            <a:schemeClr val="accent1">
+              <a:shade val="15000"/>
+            </a:schemeClr>
+          </a:lnRef>
+          <a:fillRef idx="1">
+            <a:schemeClr val="accent1"/>
+          </a:fillRef>
+          <a:effectRef idx="0">
+            <a:schemeClr val="accent1"/>
+          </a:effectRef>
+          <a:fontRef idx="minor">
+            <a:schemeClr val="lt1"/>
+          </a:fontRef>
+        </p:style>
+        <p:txBody>
+          <a:bodyPr rtlCol="0" anchor="ctr"/>
+          <a:lstStyle/>
+          <a:p>
+            <a:pPr algn="ctr"/>
+            <a:r>
+              <a:rPr lang="en-US" dirty="0"/>
+              <a:t>OUTPUT Dataset</a:t>
             </a:r>
           </a:p>
         </p:txBody>
@@ -6453,7 +7106,7 @@
     </p:spTree>
     <p:extLst>
       <p:ext uri="{BB962C8B-B14F-4D97-AF65-F5344CB8AC3E}">
-        <p14:creationId xmlns:p14="http://schemas.microsoft.com/office/powerpoint/2010/main" val="870742400"/>
+        <p14:creationId xmlns:p14="http://schemas.microsoft.com/office/powerpoint/2010/main" val="2397911183"/>
       </p:ext>
     </p:extLst>
   </p:cSld>
@@ -6463,7 +7116,433 @@
 </p:sld>
 </file>
 
-<file path=ppt/slides/slide3.xml><?xml version="1.0" encoding="utf-8"?>
+<file path=ppt/slides/slide11.xml><?xml version="1.0" encoding="utf-8"?>
+<p:sld xmlns:a="http://schemas.openxmlformats.org/drawingml/2006/main" xmlns:r="http://schemas.openxmlformats.org/officeDocument/2006/relationships" xmlns:p="http://schemas.openxmlformats.org/presentationml/2006/main">
+  <p:cSld>
+    <p:spTree>
+      <p:nvGrpSpPr>
+        <p:cNvPr id="1" name="">
+          <a:extLst>
+            <a:ext uri="{FF2B5EF4-FFF2-40B4-BE49-F238E27FC236}">
+              <a16:creationId xmlns:a16="http://schemas.microsoft.com/office/drawing/2014/main" id="{CFD92A1D-02C1-D8AA-0C03-F7A27948A85B}"/>
+            </a:ext>
+          </a:extLst>
+        </p:cNvPr>
+        <p:cNvGrpSpPr/>
+        <p:nvPr/>
+      </p:nvGrpSpPr>
+      <p:grpSpPr>
+        <a:xfrm>
+          <a:off x="0" y="0"/>
+          <a:ext cx="0" cy="0"/>
+          <a:chOff x="0" y="0"/>
+          <a:chExt cx="0" cy="0"/>
+        </a:xfrm>
+      </p:grpSpPr>
+      <p:sp>
+        <p:nvSpPr>
+          <p:cNvPr id="2" name="Title 1">
+            <a:extLst>
+              <a:ext uri="{FF2B5EF4-FFF2-40B4-BE49-F238E27FC236}">
+                <a16:creationId xmlns:a16="http://schemas.microsoft.com/office/drawing/2014/main" id="{FA5D6687-9BC1-4B75-E57B-44FBCE1B1539}"/>
+              </a:ext>
+            </a:extLst>
+          </p:cNvPr>
+          <p:cNvSpPr>
+            <a:spLocks noGrp="1"/>
+          </p:cNvSpPr>
+          <p:nvPr>
+            <p:ph type="title"/>
+          </p:nvPr>
+        </p:nvSpPr>
+        <p:spPr>
+          <a:xfrm>
+            <a:off x="502920" y="437430"/>
+            <a:ext cx="11446064" cy="478155"/>
+          </a:xfrm>
+        </p:spPr>
+        <p:txBody>
+          <a:bodyPr/>
+          <a:lstStyle/>
+          <a:p>
+            <a:r>
+              <a:rPr lang="en-GB" dirty="0"/>
+              <a:t>Intermediate Datasets for EEG-Coherence Example</a:t>
+            </a:r>
+          </a:p>
+        </p:txBody>
+      </p:sp>
+      <p:sp>
+        <p:nvSpPr>
+          <p:cNvPr id="5" name="Rectangle 4">
+            <a:extLst>
+              <a:ext uri="{FF2B5EF4-FFF2-40B4-BE49-F238E27FC236}">
+                <a16:creationId xmlns:a16="http://schemas.microsoft.com/office/drawing/2014/main" id="{309D2E30-7A85-560C-7BF3-7F796FD9E94D}"/>
+              </a:ext>
+            </a:extLst>
+          </p:cNvPr>
+          <p:cNvSpPr/>
+          <p:nvPr/>
+        </p:nvSpPr>
+        <p:spPr>
+          <a:xfrm>
+            <a:off x="146427" y="2514600"/>
+            <a:ext cx="914400" cy="914400"/>
+          </a:xfrm>
+          <a:prstGeom prst="rect">
+            <a:avLst/>
+          </a:prstGeom>
+        </p:spPr>
+        <p:style>
+          <a:lnRef idx="2">
+            <a:schemeClr val="accent1">
+              <a:shade val="15000"/>
+            </a:schemeClr>
+          </a:lnRef>
+          <a:fillRef idx="1">
+            <a:schemeClr val="accent1"/>
+          </a:fillRef>
+          <a:effectRef idx="0">
+            <a:schemeClr val="accent1"/>
+          </a:effectRef>
+          <a:fontRef idx="minor">
+            <a:schemeClr val="lt1"/>
+          </a:fontRef>
+        </p:style>
+        <p:txBody>
+          <a:bodyPr rtlCol="0" anchor="ctr"/>
+          <a:lstStyle/>
+          <a:p>
+            <a:pPr algn="ctr"/>
+            <a:r>
+              <a:rPr lang="en-US" dirty="0"/>
+              <a:t>INPUT Dataset</a:t>
+            </a:r>
+          </a:p>
+        </p:txBody>
+      </p:sp>
+      <p:sp>
+        <p:nvSpPr>
+          <p:cNvPr id="6" name="Rectangle 5">
+            <a:extLst>
+              <a:ext uri="{FF2B5EF4-FFF2-40B4-BE49-F238E27FC236}">
+                <a16:creationId xmlns:a16="http://schemas.microsoft.com/office/drawing/2014/main" id="{E1621C7A-E6AE-8374-B140-55A9F99DC095}"/>
+              </a:ext>
+            </a:extLst>
+          </p:cNvPr>
+          <p:cNvSpPr/>
+          <p:nvPr/>
+        </p:nvSpPr>
+        <p:spPr>
+          <a:xfrm>
+            <a:off x="11074332" y="2477527"/>
+            <a:ext cx="971241" cy="914400"/>
+          </a:xfrm>
+          <a:prstGeom prst="rect">
+            <a:avLst/>
+          </a:prstGeom>
+        </p:spPr>
+        <p:style>
+          <a:lnRef idx="2">
+            <a:schemeClr val="accent1">
+              <a:shade val="15000"/>
+            </a:schemeClr>
+          </a:lnRef>
+          <a:fillRef idx="1">
+            <a:schemeClr val="accent1"/>
+          </a:fillRef>
+          <a:effectRef idx="0">
+            <a:schemeClr val="accent1"/>
+          </a:effectRef>
+          <a:fontRef idx="minor">
+            <a:schemeClr val="lt1"/>
+          </a:fontRef>
+        </p:style>
+        <p:txBody>
+          <a:bodyPr rtlCol="0" anchor="ctr"/>
+          <a:lstStyle/>
+          <a:p>
+            <a:pPr algn="ctr"/>
+            <a:r>
+              <a:rPr lang="en-US" dirty="0"/>
+              <a:t>OUTPUT Dataset</a:t>
+            </a:r>
+          </a:p>
+        </p:txBody>
+      </p:sp>
+      <p:sp>
+        <p:nvSpPr>
+          <p:cNvPr id="8" name="Content Placeholder 7">
+            <a:extLst>
+              <a:ext uri="{FF2B5EF4-FFF2-40B4-BE49-F238E27FC236}">
+                <a16:creationId xmlns:a16="http://schemas.microsoft.com/office/drawing/2014/main" id="{409B842D-45C3-CA2E-A10E-E5915DC6D878}"/>
+              </a:ext>
+            </a:extLst>
+          </p:cNvPr>
+          <p:cNvSpPr>
+            <a:spLocks noGrp="1"/>
+          </p:cNvSpPr>
+          <p:nvPr>
+            <p:ph sz="half" idx="1"/>
+          </p:nvPr>
+        </p:nvSpPr>
+        <p:spPr>
+          <a:xfrm>
+            <a:off x="1771958" y="1148352"/>
+            <a:ext cx="8648084" cy="4597540"/>
+          </a:xfrm>
+          <a:ln>
+            <a:solidFill>
+              <a:schemeClr val="tx1"/>
+            </a:solidFill>
+          </a:ln>
+        </p:spPr>
+        <p:txBody>
+          <a:bodyPr>
+            <a:normAutofit/>
+          </a:bodyPr>
+          <a:lstStyle/>
+          <a:p>
+            <a:r>
+              <a:rPr lang="en-US" sz="1600" dirty="0"/>
+              <a:t>Processing steps:</a:t>
+            </a:r>
+          </a:p>
+          <a:p>
+            <a:pPr marL="457200" indent="-457200">
+              <a:buAutoNum type="arabicPeriod"/>
+            </a:pPr>
+            <a:r>
+              <a:rPr lang="en-US" sz="1600" b="1" dirty="0"/>
+              <a:t>Windowing (time domain)</a:t>
+            </a:r>
+            <a:r>
+              <a:rPr lang="en-US" sz="1600" dirty="0"/>
+              <a:t> : window of pre-determined length around each timepoint in each epoch for each channel </a:t>
+            </a:r>
+            <a:r>
+              <a:rPr lang="en-US" sz="1600" b="1" dirty="0"/>
+              <a:t>(timepoints x windows x epochs x channels)</a:t>
+            </a:r>
+          </a:p>
+          <a:p>
+            <a:pPr marL="457200" indent="-457200">
+              <a:buAutoNum type="arabicPeriod"/>
+            </a:pPr>
+            <a:r>
+              <a:rPr lang="en-US" sz="1600" b="1" dirty="0"/>
+              <a:t>Transformation (time to frequency)</a:t>
+            </a:r>
+            <a:r>
+              <a:rPr lang="en-US" sz="1600" dirty="0"/>
+              <a:t>: calculate power per frequency band in each overlapping window of each epoch and channel using Fourier transform </a:t>
+            </a:r>
+            <a:r>
+              <a:rPr lang="en-US" sz="1600" b="1" dirty="0"/>
+              <a:t>(timepoints x epochs x channels x </a:t>
+            </a:r>
+            <a:r>
+              <a:rPr lang="en-US" sz="1600" b="1" dirty="0" err="1"/>
+              <a:t>frequency_bin</a:t>
+            </a:r>
+            <a:r>
+              <a:rPr lang="en-US" sz="1600" b="1" dirty="0"/>
+              <a:t>)</a:t>
+            </a:r>
+          </a:p>
+          <a:p>
+            <a:pPr marL="457200" indent="-457200">
+              <a:buAutoNum type="arabicPeriod"/>
+            </a:pPr>
+            <a:r>
+              <a:rPr lang="en-US" sz="1600" b="1" dirty="0"/>
+              <a:t>Windowing and averaging (frequency domain)</a:t>
+            </a:r>
+            <a:r>
+              <a:rPr lang="en-US" sz="1600" dirty="0"/>
+              <a:t> : averaging signal power at each timepoint in every epoch during selected frequencies of interest (e.g. beta band 13-30Hz) </a:t>
+            </a:r>
+            <a:r>
+              <a:rPr lang="en-US" sz="1600" b="1" dirty="0"/>
+              <a:t>(timepoints x epochs x channels)</a:t>
+            </a:r>
+          </a:p>
+          <a:p>
+            <a:pPr marL="457200" indent="-457200">
+              <a:buAutoNum type="arabicPeriod"/>
+            </a:pPr>
+            <a:r>
+              <a:rPr lang="en-US" sz="1600" b="1" dirty="0"/>
+              <a:t>Averaging (epoch space)</a:t>
+            </a:r>
+            <a:r>
+              <a:rPr lang="en-US" sz="1600" dirty="0"/>
+              <a:t> : averaging power at each timepoint in all epochs for all channels </a:t>
+            </a:r>
+            <a:r>
+              <a:rPr lang="en-US" sz="1600" b="1" dirty="0"/>
+              <a:t>(timepoints x channels)</a:t>
+            </a:r>
+          </a:p>
+          <a:p>
+            <a:pPr marL="457200" indent="-457200">
+              <a:buAutoNum type="arabicPeriod"/>
+            </a:pPr>
+            <a:r>
+              <a:rPr lang="en-US" sz="1600" b="1" dirty="0"/>
+              <a:t>Windowing and averaging (channel space)</a:t>
+            </a:r>
+            <a:r>
+              <a:rPr lang="en-US" sz="1600" dirty="0"/>
+              <a:t> : selecting subset of channels to be used in connectivity evaluation </a:t>
+            </a:r>
+            <a:r>
+              <a:rPr lang="en-US" sz="1600" b="1" dirty="0"/>
+              <a:t>(timepoints x </a:t>
+            </a:r>
+            <a:r>
+              <a:rPr lang="en-US" sz="1600" b="1" dirty="0" err="1"/>
+              <a:t>connectivity_level</a:t>
+            </a:r>
+            <a:r>
+              <a:rPr lang="en-US" sz="1600" b="1" dirty="0"/>
+              <a:t>)</a:t>
+            </a:r>
+          </a:p>
+          <a:p>
+            <a:pPr marL="457200" indent="-457200">
+              <a:buAutoNum type="arabicPeriod"/>
+            </a:pPr>
+            <a:r>
+              <a:rPr lang="en-US" sz="1600" b="1" dirty="0"/>
+              <a:t>Correlation</a:t>
+            </a:r>
+            <a:r>
+              <a:rPr lang="en-US" sz="1600" dirty="0"/>
+              <a:t> : finding connectivity between selected channels </a:t>
+            </a:r>
+            <a:r>
+              <a:rPr lang="en-US" sz="1600" b="1" dirty="0"/>
+              <a:t>(timepoints x connectivity _level x </a:t>
+            </a:r>
+            <a:r>
+              <a:rPr lang="en-US" sz="1600" b="1" dirty="0" err="1"/>
+              <a:t>connectivity_metric</a:t>
+            </a:r>
+            <a:r>
+              <a:rPr lang="en-US" sz="1600" b="1" dirty="0"/>
+              <a:t>)</a:t>
+            </a:r>
+            <a:endParaRPr lang="en-US" sz="1600" dirty="0"/>
+          </a:p>
+        </p:txBody>
+      </p:sp>
+      <p:sp>
+        <p:nvSpPr>
+          <p:cNvPr id="9" name="Right Arrow 8">
+            <a:extLst>
+              <a:ext uri="{FF2B5EF4-FFF2-40B4-BE49-F238E27FC236}">
+                <a16:creationId xmlns:a16="http://schemas.microsoft.com/office/drawing/2014/main" id="{5DD0E048-5CAB-57CF-A516-E67527488895}"/>
+              </a:ext>
+            </a:extLst>
+          </p:cNvPr>
+          <p:cNvSpPr/>
+          <p:nvPr/>
+        </p:nvSpPr>
+        <p:spPr>
+          <a:xfrm>
+            <a:off x="1228570" y="2934727"/>
+            <a:ext cx="432486" cy="154457"/>
+          </a:xfrm>
+          <a:prstGeom prst="rightArrow">
+            <a:avLst/>
+          </a:prstGeom>
+        </p:spPr>
+        <p:style>
+          <a:lnRef idx="2">
+            <a:schemeClr val="accent1">
+              <a:shade val="15000"/>
+            </a:schemeClr>
+          </a:lnRef>
+          <a:fillRef idx="1">
+            <a:schemeClr val="accent1"/>
+          </a:fillRef>
+          <a:effectRef idx="0">
+            <a:schemeClr val="accent1"/>
+          </a:effectRef>
+          <a:fontRef idx="minor">
+            <a:schemeClr val="lt1"/>
+          </a:fontRef>
+        </p:style>
+        <p:txBody>
+          <a:bodyPr rtlCol="0" anchor="ctr"/>
+          <a:lstStyle/>
+          <a:p>
+            <a:pPr algn="ctr"/>
+            <a:endParaRPr lang="en-US"/>
+          </a:p>
+        </p:txBody>
+      </p:sp>
+      <p:sp>
+        <p:nvSpPr>
+          <p:cNvPr id="10" name="Right Arrow 9">
+            <a:extLst>
+              <a:ext uri="{FF2B5EF4-FFF2-40B4-BE49-F238E27FC236}">
+                <a16:creationId xmlns:a16="http://schemas.microsoft.com/office/drawing/2014/main" id="{A74AF5AD-FCEB-87EF-1F9E-2B40B073AF83}"/>
+              </a:ext>
+            </a:extLst>
+          </p:cNvPr>
+          <p:cNvSpPr/>
+          <p:nvPr/>
+        </p:nvSpPr>
+        <p:spPr>
+          <a:xfrm>
+            <a:off x="10530944" y="2894571"/>
+            <a:ext cx="432486" cy="154457"/>
+          </a:xfrm>
+          <a:prstGeom prst="rightArrow">
+            <a:avLst/>
+          </a:prstGeom>
+        </p:spPr>
+        <p:style>
+          <a:lnRef idx="2">
+            <a:schemeClr val="accent1">
+              <a:shade val="15000"/>
+            </a:schemeClr>
+          </a:lnRef>
+          <a:fillRef idx="1">
+            <a:schemeClr val="accent1"/>
+          </a:fillRef>
+          <a:effectRef idx="0">
+            <a:schemeClr val="accent1"/>
+          </a:effectRef>
+          <a:fontRef idx="minor">
+            <a:schemeClr val="lt1"/>
+          </a:fontRef>
+        </p:style>
+        <p:txBody>
+          <a:bodyPr rtlCol="0" anchor="ctr"/>
+          <a:lstStyle/>
+          <a:p>
+            <a:pPr algn="ctr"/>
+            <a:endParaRPr lang="en-US"/>
+          </a:p>
+        </p:txBody>
+      </p:sp>
+    </p:spTree>
+    <p:extLst>
+      <p:ext uri="{BB962C8B-B14F-4D97-AF65-F5344CB8AC3E}">
+        <p14:creationId xmlns:p14="http://schemas.microsoft.com/office/powerpoint/2010/main" val="3780145383"/>
+      </p:ext>
+    </p:extLst>
+  </p:cSld>
+  <p:clrMapOvr>
+    <a:masterClrMapping/>
+  </p:clrMapOvr>
+</p:sld>
+</file>
+
+<file path=ppt/slides/slide2.xml><?xml version="1.0" encoding="utf-8"?>
 <p:sld xmlns:a="http://schemas.openxmlformats.org/drawingml/2006/main" xmlns:r="http://schemas.openxmlformats.org/officeDocument/2006/relationships" xmlns:p="http://schemas.openxmlformats.org/presentationml/2006/main">
   <p:cSld>
     <p:spTree>
@@ -6628,6 +7707,272 @@
     <p:extLst>
       <p:ext uri="{BB962C8B-B14F-4D97-AF65-F5344CB8AC3E}">
         <p14:creationId xmlns:p14="http://schemas.microsoft.com/office/powerpoint/2010/main" val="906623838"/>
+      </p:ext>
+    </p:extLst>
+  </p:cSld>
+  <p:clrMapOvr>
+    <a:masterClrMapping/>
+  </p:clrMapOvr>
+</p:sld>
+</file>
+
+<file path=ppt/slides/slide3.xml><?xml version="1.0" encoding="utf-8"?>
+<p:sld xmlns:a="http://schemas.openxmlformats.org/drawingml/2006/main" xmlns:r="http://schemas.openxmlformats.org/officeDocument/2006/relationships" xmlns:p="http://schemas.openxmlformats.org/presentationml/2006/main">
+  <p:cSld>
+    <p:spTree>
+      <p:nvGrpSpPr>
+        <p:cNvPr id="1" name=""/>
+        <p:cNvGrpSpPr/>
+        <p:nvPr/>
+      </p:nvGrpSpPr>
+      <p:grpSpPr>
+        <a:xfrm>
+          <a:off x="0" y="0"/>
+          <a:ext cx="0" cy="0"/>
+          <a:chOff x="0" y="0"/>
+          <a:chExt cx="0" cy="0"/>
+        </a:xfrm>
+      </p:grpSpPr>
+      <p:sp>
+        <p:nvSpPr>
+          <p:cNvPr id="2" name="Title 1">
+            <a:extLst>
+              <a:ext uri="{FF2B5EF4-FFF2-40B4-BE49-F238E27FC236}">
+                <a16:creationId xmlns:a16="http://schemas.microsoft.com/office/drawing/2014/main" id="{593C6542-E0B7-C741-85FE-6F66ADF534B4}"/>
+              </a:ext>
+            </a:extLst>
+          </p:cNvPr>
+          <p:cNvSpPr>
+            <a:spLocks noGrp="1"/>
+          </p:cNvSpPr>
+          <p:nvPr>
+            <p:ph type="title"/>
+          </p:nvPr>
+        </p:nvSpPr>
+        <p:spPr/>
+        <p:txBody>
+          <a:bodyPr/>
+          <a:lstStyle/>
+          <a:p>
+            <a:r>
+              <a:rPr lang="en-GB" dirty="0"/>
+              <a:t>Searching For Alternative Example</a:t>
+            </a:r>
+          </a:p>
+        </p:txBody>
+      </p:sp>
+      <p:sp>
+        <p:nvSpPr>
+          <p:cNvPr id="3" name="Content Placeholder 2">
+            <a:extLst>
+              <a:ext uri="{FF2B5EF4-FFF2-40B4-BE49-F238E27FC236}">
+                <a16:creationId xmlns:a16="http://schemas.microsoft.com/office/drawing/2014/main" id="{77A62677-4C55-29F7-0541-52755F736C4C}"/>
+              </a:ext>
+            </a:extLst>
+          </p:cNvPr>
+          <p:cNvSpPr>
+            <a:spLocks noGrp="1"/>
+          </p:cNvSpPr>
+          <p:nvPr>
+            <p:ph sz="half" idx="1"/>
+          </p:nvPr>
+        </p:nvSpPr>
+        <p:spPr/>
+        <p:txBody>
+          <a:bodyPr>
+            <a:normAutofit fontScale="70000" lnSpcReduction="20000"/>
+          </a:bodyPr>
+          <a:lstStyle/>
+          <a:p>
+            <a:pPr marL="342900" indent="-342900">
+              <a:buFont typeface="Arial" panose="020B0604020202020204" pitchFamily="34" charset="0"/>
+              <a:buChar char="•"/>
+            </a:pPr>
+            <a:r>
+              <a:rPr lang="en-GB" dirty="0"/>
+              <a:t>Instead of MRI, focus on data/output/metrics obtained using electrophysiological neuroimaging methods.</a:t>
+            </a:r>
+          </a:p>
+          <a:p>
+            <a:pPr marL="342900" indent="-342900">
+              <a:buFont typeface="Arial" panose="020B0604020202020204" pitchFamily="34" charset="0"/>
+              <a:buChar char="•"/>
+            </a:pPr>
+            <a:endParaRPr lang="en-GB" dirty="0"/>
+          </a:p>
+          <a:p>
+            <a:pPr marL="342900" indent="-342900">
+              <a:buFont typeface="Arial" panose="020B0604020202020204" pitchFamily="34" charset="0"/>
+              <a:buChar char="•"/>
+            </a:pPr>
+            <a:r>
+              <a:rPr lang="en-GB" dirty="0"/>
+              <a:t>MRI </a:t>
+            </a:r>
+          </a:p>
+          <a:p>
+            <a:pPr marL="800100" lvl="1" indent="-342900">
+              <a:buFont typeface="Arial" panose="020B0604020202020204" pitchFamily="34" charset="0"/>
+              <a:buChar char="•"/>
+            </a:pPr>
+            <a:r>
+              <a:rPr lang="en-GB" dirty="0"/>
+              <a:t>obtain brain activity in terms of oxygen consumption </a:t>
+            </a:r>
+          </a:p>
+          <a:p>
+            <a:pPr marL="800100" lvl="1" indent="-342900">
+              <a:buFont typeface="Arial" panose="020B0604020202020204" pitchFamily="34" charset="0"/>
+              <a:buChar char="•"/>
+            </a:pPr>
+            <a:r>
+              <a:rPr lang="en-GB" dirty="0"/>
+              <a:t>gives structure, function, pathway information</a:t>
+            </a:r>
+          </a:p>
+          <a:p>
+            <a:pPr marL="800100" lvl="1" indent="-342900">
+              <a:buFont typeface="Arial" panose="020B0604020202020204" pitchFamily="34" charset="0"/>
+              <a:buChar char="•"/>
+            </a:pPr>
+            <a:r>
+              <a:rPr lang="en-GB" dirty="0"/>
+              <a:t>Need triaxial, 3D view to display output along with help from brain-atlases</a:t>
+            </a:r>
+          </a:p>
+          <a:p>
+            <a:pPr marL="800100" lvl="1" indent="-342900">
+              <a:buFont typeface="Arial" panose="020B0604020202020204" pitchFamily="34" charset="0"/>
+              <a:buChar char="•"/>
+            </a:pPr>
+            <a:r>
+              <a:rPr lang="en-GB" dirty="0"/>
+              <a:t>Dense and overlapping outputs</a:t>
+            </a:r>
+          </a:p>
+          <a:p>
+            <a:pPr marL="800100" lvl="1" indent="-342900">
+              <a:buFont typeface="Arial" panose="020B0604020202020204" pitchFamily="34" charset="0"/>
+              <a:buChar char="•"/>
+            </a:pPr>
+            <a:r>
+              <a:rPr lang="en-GB" b="1" dirty="0"/>
+              <a:t>Eventually need to handle this output but difficult to begin with</a:t>
+            </a:r>
+          </a:p>
+          <a:p>
+            <a:pPr marL="342900" indent="-342900">
+              <a:buFont typeface="Arial" panose="020B0604020202020204" pitchFamily="34" charset="0"/>
+              <a:buChar char="•"/>
+            </a:pPr>
+            <a:r>
+              <a:rPr lang="en-GB" dirty="0"/>
+              <a:t>EEG/MEG</a:t>
+            </a:r>
+          </a:p>
+          <a:p>
+            <a:pPr marL="800100" lvl="1" indent="-342900">
+              <a:buFont typeface="Arial" panose="020B0604020202020204" pitchFamily="34" charset="0"/>
+              <a:buChar char="•"/>
+            </a:pPr>
+            <a:r>
+              <a:rPr lang="en-GB" dirty="0"/>
+              <a:t>Obtain brain activity in terms of electromagnetics in the brain</a:t>
+            </a:r>
+          </a:p>
+          <a:p>
+            <a:pPr marL="800100" lvl="1" indent="-342900">
+              <a:buFont typeface="Arial" panose="020B0604020202020204" pitchFamily="34" charset="0"/>
+              <a:buChar char="•"/>
+            </a:pPr>
+            <a:r>
+              <a:rPr lang="en-GB" dirty="0"/>
+              <a:t>Gives function, connectivity, network and temporal information</a:t>
+            </a:r>
+          </a:p>
+          <a:p>
+            <a:pPr marL="800100" lvl="1" indent="-342900">
+              <a:buFont typeface="Arial" panose="020B0604020202020204" pitchFamily="34" charset="0"/>
+              <a:buChar char="•"/>
+            </a:pPr>
+            <a:r>
+              <a:rPr lang="en-GB" dirty="0"/>
+              <a:t>Easy to incorporate with fluid given the outputs are mostly line graphs, topographical plots, matrices</a:t>
+            </a:r>
+          </a:p>
+          <a:p>
+            <a:pPr marL="800100" lvl="1" indent="-342900">
+              <a:buFont typeface="Arial" panose="020B0604020202020204" pitchFamily="34" charset="0"/>
+              <a:buChar char="•"/>
+            </a:pPr>
+            <a:r>
+              <a:rPr lang="en-GB" dirty="0"/>
+              <a:t>Need more functions such as multiple cascading plots/graphs, multi-level selection etc</a:t>
+            </a:r>
+          </a:p>
+          <a:p>
+            <a:pPr marL="342900" indent="-342900">
+              <a:buFont typeface="Arial" panose="020B0604020202020204" pitchFamily="34" charset="0"/>
+              <a:buChar char="•"/>
+            </a:pPr>
+            <a:r>
+              <a:rPr lang="en-GB" dirty="0"/>
+              <a:t>Computational/</a:t>
+            </a:r>
+            <a:r>
+              <a:rPr lang="en-GB" dirty="0" err="1"/>
+              <a:t>Behavioral</a:t>
+            </a:r>
+            <a:r>
+              <a:rPr lang="en-GB" dirty="0"/>
+              <a:t> methods</a:t>
+            </a:r>
+          </a:p>
+          <a:p>
+            <a:pPr marL="800100" lvl="1" indent="-342900">
+              <a:buFont typeface="Arial" panose="020B0604020202020204" pitchFamily="34" charset="0"/>
+              <a:buChar char="•"/>
+            </a:pPr>
+            <a:r>
+              <a:rPr lang="en-GB" dirty="0"/>
+              <a:t>RT-based studies, Eye-tracking, tapping, motor tests</a:t>
+            </a:r>
+          </a:p>
+          <a:p>
+            <a:pPr marL="342900" indent="-342900">
+              <a:buFont typeface="Arial" panose="020B0604020202020204" pitchFamily="34" charset="0"/>
+              <a:buChar char="•"/>
+            </a:pPr>
+            <a:r>
+              <a:rPr lang="en-GB" dirty="0"/>
+              <a:t>Other neuroimaging methods</a:t>
+            </a:r>
+          </a:p>
+          <a:p>
+            <a:pPr marL="800100" lvl="1" indent="-342900">
+              <a:buFont typeface="Arial" panose="020B0604020202020204" pitchFamily="34" charset="0"/>
+              <a:buChar char="•"/>
+            </a:pPr>
+            <a:r>
+              <a:rPr lang="en-GB" dirty="0" err="1"/>
+              <a:t>fNIRS</a:t>
+            </a:r>
+            <a:r>
+              <a:rPr lang="en-GB" dirty="0"/>
+              <a:t>, TMS, LFP, </a:t>
+            </a:r>
+            <a:r>
+              <a:rPr lang="en-GB" dirty="0" err="1"/>
+              <a:t>ECoG</a:t>
+            </a:r>
+            <a:endParaRPr lang="en-GB" dirty="0"/>
+          </a:p>
+        </p:txBody>
+      </p:sp>
+    </p:spTree>
+    <p:extLst>
+      <p:ext uri="{BB962C8B-B14F-4D97-AF65-F5344CB8AC3E}">
+        <p14:creationId xmlns:p14="http://schemas.microsoft.com/office/powerpoint/2010/main" val="1514807859"/>
       </p:ext>
     </p:extLst>
   </p:cSld>
@@ -6659,272 +8004,6 @@
           <p:cNvPr id="2" name="Title 1">
             <a:extLst>
               <a:ext uri="{FF2B5EF4-FFF2-40B4-BE49-F238E27FC236}">
-                <a16:creationId xmlns:a16="http://schemas.microsoft.com/office/drawing/2014/main" id="{593C6542-E0B7-C741-85FE-6F66ADF534B4}"/>
-              </a:ext>
-            </a:extLst>
-          </p:cNvPr>
-          <p:cNvSpPr>
-            <a:spLocks noGrp="1"/>
-          </p:cNvSpPr>
-          <p:nvPr>
-            <p:ph type="title"/>
-          </p:nvPr>
-        </p:nvSpPr>
-        <p:spPr/>
-        <p:txBody>
-          <a:bodyPr/>
-          <a:lstStyle/>
-          <a:p>
-            <a:r>
-              <a:rPr lang="en-GB" dirty="0"/>
-              <a:t>Searching For Alternative Example</a:t>
-            </a:r>
-          </a:p>
-        </p:txBody>
-      </p:sp>
-      <p:sp>
-        <p:nvSpPr>
-          <p:cNvPr id="3" name="Content Placeholder 2">
-            <a:extLst>
-              <a:ext uri="{FF2B5EF4-FFF2-40B4-BE49-F238E27FC236}">
-                <a16:creationId xmlns:a16="http://schemas.microsoft.com/office/drawing/2014/main" id="{77A62677-4C55-29F7-0541-52755F736C4C}"/>
-              </a:ext>
-            </a:extLst>
-          </p:cNvPr>
-          <p:cNvSpPr>
-            <a:spLocks noGrp="1"/>
-          </p:cNvSpPr>
-          <p:nvPr>
-            <p:ph sz="half" idx="1"/>
-          </p:nvPr>
-        </p:nvSpPr>
-        <p:spPr/>
-        <p:txBody>
-          <a:bodyPr>
-            <a:normAutofit fontScale="70000" lnSpcReduction="20000"/>
-          </a:bodyPr>
-          <a:lstStyle/>
-          <a:p>
-            <a:pPr marL="342900" indent="-342900">
-              <a:buFont typeface="Arial" panose="020B0604020202020204" pitchFamily="34" charset="0"/>
-              <a:buChar char="•"/>
-            </a:pPr>
-            <a:r>
-              <a:rPr lang="en-GB" dirty="0"/>
-              <a:t>Instead of MRI, focus on data/output/metrics obtained using electrophysiological neuroimaging methods.</a:t>
-            </a:r>
-          </a:p>
-          <a:p>
-            <a:pPr marL="342900" indent="-342900">
-              <a:buFont typeface="Arial" panose="020B0604020202020204" pitchFamily="34" charset="0"/>
-              <a:buChar char="•"/>
-            </a:pPr>
-            <a:endParaRPr lang="en-GB" dirty="0"/>
-          </a:p>
-          <a:p>
-            <a:pPr marL="342900" indent="-342900">
-              <a:buFont typeface="Arial" panose="020B0604020202020204" pitchFamily="34" charset="0"/>
-              <a:buChar char="•"/>
-            </a:pPr>
-            <a:r>
-              <a:rPr lang="en-GB" dirty="0"/>
-              <a:t>MRI </a:t>
-            </a:r>
-          </a:p>
-          <a:p>
-            <a:pPr marL="800100" lvl="1" indent="-342900">
-              <a:buFont typeface="Arial" panose="020B0604020202020204" pitchFamily="34" charset="0"/>
-              <a:buChar char="•"/>
-            </a:pPr>
-            <a:r>
-              <a:rPr lang="en-GB" dirty="0"/>
-              <a:t>obtain brain activity in terms of oxygen consumption </a:t>
-            </a:r>
-          </a:p>
-          <a:p>
-            <a:pPr marL="800100" lvl="1" indent="-342900">
-              <a:buFont typeface="Arial" panose="020B0604020202020204" pitchFamily="34" charset="0"/>
-              <a:buChar char="•"/>
-            </a:pPr>
-            <a:r>
-              <a:rPr lang="en-GB" dirty="0"/>
-              <a:t>gives structure, function, pathway information</a:t>
-            </a:r>
-          </a:p>
-          <a:p>
-            <a:pPr marL="800100" lvl="1" indent="-342900">
-              <a:buFont typeface="Arial" panose="020B0604020202020204" pitchFamily="34" charset="0"/>
-              <a:buChar char="•"/>
-            </a:pPr>
-            <a:r>
-              <a:rPr lang="en-GB" dirty="0"/>
-              <a:t>Need triaxial, 3D view to display output along with help from brain-atlases</a:t>
-            </a:r>
-          </a:p>
-          <a:p>
-            <a:pPr marL="800100" lvl="1" indent="-342900">
-              <a:buFont typeface="Arial" panose="020B0604020202020204" pitchFamily="34" charset="0"/>
-              <a:buChar char="•"/>
-            </a:pPr>
-            <a:r>
-              <a:rPr lang="en-GB" dirty="0"/>
-              <a:t>Dense and overlapping outputs</a:t>
-            </a:r>
-          </a:p>
-          <a:p>
-            <a:pPr marL="800100" lvl="1" indent="-342900">
-              <a:buFont typeface="Arial" panose="020B0604020202020204" pitchFamily="34" charset="0"/>
-              <a:buChar char="•"/>
-            </a:pPr>
-            <a:r>
-              <a:rPr lang="en-GB" b="1" dirty="0"/>
-              <a:t>Eventually need to handle this output but difficult to begin with</a:t>
-            </a:r>
-          </a:p>
-          <a:p>
-            <a:pPr marL="342900" indent="-342900">
-              <a:buFont typeface="Arial" panose="020B0604020202020204" pitchFamily="34" charset="0"/>
-              <a:buChar char="•"/>
-            </a:pPr>
-            <a:r>
-              <a:rPr lang="en-GB" dirty="0"/>
-              <a:t>EEG/MEG</a:t>
-            </a:r>
-          </a:p>
-          <a:p>
-            <a:pPr marL="800100" lvl="1" indent="-342900">
-              <a:buFont typeface="Arial" panose="020B0604020202020204" pitchFamily="34" charset="0"/>
-              <a:buChar char="•"/>
-            </a:pPr>
-            <a:r>
-              <a:rPr lang="en-GB" dirty="0"/>
-              <a:t>Obtain brain activity in terms of electromagnetics in the brain</a:t>
-            </a:r>
-          </a:p>
-          <a:p>
-            <a:pPr marL="800100" lvl="1" indent="-342900">
-              <a:buFont typeface="Arial" panose="020B0604020202020204" pitchFamily="34" charset="0"/>
-              <a:buChar char="•"/>
-            </a:pPr>
-            <a:r>
-              <a:rPr lang="en-GB" dirty="0"/>
-              <a:t>Gives function, connectivity, network and temporal information</a:t>
-            </a:r>
-          </a:p>
-          <a:p>
-            <a:pPr marL="800100" lvl="1" indent="-342900">
-              <a:buFont typeface="Arial" panose="020B0604020202020204" pitchFamily="34" charset="0"/>
-              <a:buChar char="•"/>
-            </a:pPr>
-            <a:r>
-              <a:rPr lang="en-GB" dirty="0"/>
-              <a:t>Easy to incorporate with fluid given the outputs are mostly line graphs, topographical plots, matrices</a:t>
-            </a:r>
-          </a:p>
-          <a:p>
-            <a:pPr marL="800100" lvl="1" indent="-342900">
-              <a:buFont typeface="Arial" panose="020B0604020202020204" pitchFamily="34" charset="0"/>
-              <a:buChar char="•"/>
-            </a:pPr>
-            <a:r>
-              <a:rPr lang="en-GB" dirty="0"/>
-              <a:t>Need more functions such as multiple cascading plots/graphs, multi-level selection etc</a:t>
-            </a:r>
-          </a:p>
-          <a:p>
-            <a:pPr marL="342900" indent="-342900">
-              <a:buFont typeface="Arial" panose="020B0604020202020204" pitchFamily="34" charset="0"/>
-              <a:buChar char="•"/>
-            </a:pPr>
-            <a:r>
-              <a:rPr lang="en-GB" dirty="0"/>
-              <a:t>Computational/</a:t>
-            </a:r>
-            <a:r>
-              <a:rPr lang="en-GB" dirty="0" err="1"/>
-              <a:t>Behavioral</a:t>
-            </a:r>
-            <a:r>
-              <a:rPr lang="en-GB" dirty="0"/>
-              <a:t> methods</a:t>
-            </a:r>
-          </a:p>
-          <a:p>
-            <a:pPr marL="800100" lvl="1" indent="-342900">
-              <a:buFont typeface="Arial" panose="020B0604020202020204" pitchFamily="34" charset="0"/>
-              <a:buChar char="•"/>
-            </a:pPr>
-            <a:r>
-              <a:rPr lang="en-GB" dirty="0"/>
-              <a:t>RT-based studies, Eye-tracking, tapping, motor tests</a:t>
-            </a:r>
-          </a:p>
-          <a:p>
-            <a:pPr marL="342900" indent="-342900">
-              <a:buFont typeface="Arial" panose="020B0604020202020204" pitchFamily="34" charset="0"/>
-              <a:buChar char="•"/>
-            </a:pPr>
-            <a:r>
-              <a:rPr lang="en-GB" dirty="0"/>
-              <a:t>Other neuroimaging methods</a:t>
-            </a:r>
-          </a:p>
-          <a:p>
-            <a:pPr marL="800100" lvl="1" indent="-342900">
-              <a:buFont typeface="Arial" panose="020B0604020202020204" pitchFamily="34" charset="0"/>
-              <a:buChar char="•"/>
-            </a:pPr>
-            <a:r>
-              <a:rPr lang="en-GB" dirty="0" err="1"/>
-              <a:t>fNIRS</a:t>
-            </a:r>
-            <a:r>
-              <a:rPr lang="en-GB" dirty="0"/>
-              <a:t>, TMS, LFP, </a:t>
-            </a:r>
-            <a:r>
-              <a:rPr lang="en-GB" dirty="0" err="1"/>
-              <a:t>ECoG</a:t>
-            </a:r>
-            <a:endParaRPr lang="en-GB" dirty="0"/>
-          </a:p>
-        </p:txBody>
-      </p:sp>
-    </p:spTree>
-    <p:extLst>
-      <p:ext uri="{BB962C8B-B14F-4D97-AF65-F5344CB8AC3E}">
-        <p14:creationId xmlns:p14="http://schemas.microsoft.com/office/powerpoint/2010/main" val="1514807859"/>
-      </p:ext>
-    </p:extLst>
-  </p:cSld>
-  <p:clrMapOvr>
-    <a:masterClrMapping/>
-  </p:clrMapOvr>
-</p:sld>
-</file>
-
-<file path=ppt/slides/slide5.xml><?xml version="1.0" encoding="utf-8"?>
-<p:sld xmlns:a="http://schemas.openxmlformats.org/drawingml/2006/main" xmlns:r="http://schemas.openxmlformats.org/officeDocument/2006/relationships" xmlns:p="http://schemas.openxmlformats.org/presentationml/2006/main">
-  <p:cSld>
-    <p:spTree>
-      <p:nvGrpSpPr>
-        <p:cNvPr id="1" name=""/>
-        <p:cNvGrpSpPr/>
-        <p:nvPr/>
-      </p:nvGrpSpPr>
-      <p:grpSpPr>
-        <a:xfrm>
-          <a:off x="0" y="0"/>
-          <a:ext cx="0" cy="0"/>
-          <a:chOff x="0" y="0"/>
-          <a:chExt cx="0" cy="0"/>
-        </a:xfrm>
-      </p:grpSpPr>
-      <p:sp>
-        <p:nvSpPr>
-          <p:cNvPr id="2" name="Title 1">
-            <a:extLst>
-              <a:ext uri="{FF2B5EF4-FFF2-40B4-BE49-F238E27FC236}">
                 <a16:creationId xmlns:a16="http://schemas.microsoft.com/office/drawing/2014/main" id="{C68BBB8E-11C6-E9B9-0EEF-0CD7BA501ABB}"/>
               </a:ext>
             </a:extLst>
@@ -7089,7 +8168,7 @@
 </p:sld>
 </file>
 
-<file path=ppt/slides/slide6.xml><?xml version="1.0" encoding="utf-8"?>
+<file path=ppt/slides/slide5.xml><?xml version="1.0" encoding="utf-8"?>
 <p:sld xmlns:a="http://schemas.openxmlformats.org/drawingml/2006/main" xmlns:r="http://schemas.openxmlformats.org/officeDocument/2006/relationships" xmlns:p="http://schemas.openxmlformats.org/presentationml/2006/main">
   <p:cSld>
     <p:spTree>
@@ -7887,6 +8966,163 @@
 </p:sld>
 </file>
 
+<file path=ppt/slides/slide6.xml><?xml version="1.0" encoding="utf-8"?>
+<p:sld xmlns:a="http://schemas.openxmlformats.org/drawingml/2006/main" xmlns:r="http://schemas.openxmlformats.org/officeDocument/2006/relationships" xmlns:p="http://schemas.openxmlformats.org/presentationml/2006/main">
+  <p:cSld>
+    <p:spTree>
+      <p:nvGrpSpPr>
+        <p:cNvPr id="1" name=""/>
+        <p:cNvGrpSpPr/>
+        <p:nvPr/>
+      </p:nvGrpSpPr>
+      <p:grpSpPr>
+        <a:xfrm>
+          <a:off x="0" y="0"/>
+          <a:ext cx="0" cy="0"/>
+          <a:chOff x="0" y="0"/>
+          <a:chExt cx="0" cy="0"/>
+        </a:xfrm>
+      </p:grpSpPr>
+      <p:sp>
+        <p:nvSpPr>
+          <p:cNvPr id="2" name="Title 1">
+            <a:extLst>
+              <a:ext uri="{FF2B5EF4-FFF2-40B4-BE49-F238E27FC236}">
+                <a16:creationId xmlns:a16="http://schemas.microsoft.com/office/drawing/2014/main" id="{A100F8FC-5333-9FD7-0F73-41F50092BD06}"/>
+              </a:ext>
+            </a:extLst>
+          </p:cNvPr>
+          <p:cNvSpPr>
+            <a:spLocks noGrp="1"/>
+          </p:cNvSpPr>
+          <p:nvPr>
+            <p:ph type="title"/>
+          </p:nvPr>
+        </p:nvSpPr>
+        <p:spPr/>
+        <p:txBody>
+          <a:bodyPr/>
+          <a:lstStyle/>
+          <a:p>
+            <a:r>
+              <a:rPr lang="en-GB" dirty="0"/>
+              <a:t>Future work</a:t>
+            </a:r>
+          </a:p>
+        </p:txBody>
+      </p:sp>
+      <p:sp>
+        <p:nvSpPr>
+          <p:cNvPr id="3" name="Content Placeholder 2">
+            <a:extLst>
+              <a:ext uri="{FF2B5EF4-FFF2-40B4-BE49-F238E27FC236}">
+                <a16:creationId xmlns:a16="http://schemas.microsoft.com/office/drawing/2014/main" id="{B5F85657-1037-47E1-2518-F114ADD35137}"/>
+              </a:ext>
+            </a:extLst>
+          </p:cNvPr>
+          <p:cNvSpPr>
+            <a:spLocks noGrp="1"/>
+          </p:cNvSpPr>
+          <p:nvPr>
+            <p:ph sz="half" idx="1"/>
+          </p:nvPr>
+        </p:nvSpPr>
+        <p:spPr/>
+        <p:txBody>
+          <a:bodyPr vert="horz" lIns="91440" tIns="45720" rIns="91440" bIns="45720" rtlCol="0" anchor="t">
+            <a:normAutofit/>
+          </a:bodyPr>
+          <a:lstStyle/>
+          <a:p>
+            <a:pPr marL="342900" indent="-342900">
+              <a:buFont typeface="Arial" panose="020B0604020202020204" pitchFamily="34" charset="0"/>
+              <a:buChar char="•"/>
+            </a:pPr>
+            <a:r>
+              <a:rPr lang="en-GB" dirty="0">
+                <a:latin typeface="Arial"/>
+                <a:cs typeface="Arial"/>
+              </a:rPr>
+              <a:t>Identify different types of output artefacts in neuroscience research.</a:t>
+            </a:r>
+          </a:p>
+          <a:p>
+            <a:pPr marL="342900" indent="-342900">
+              <a:buFont typeface="Arial" panose="020B0604020202020204" pitchFamily="34" charset="0"/>
+              <a:buChar char="•"/>
+            </a:pPr>
+            <a:r>
+              <a:rPr lang="en-GB" dirty="0">
+                <a:latin typeface="Arial"/>
+                <a:cs typeface="Arial"/>
+              </a:rPr>
+              <a:t>Literature survey on if/how there is a disconnect between neuroscience research outputs and data.</a:t>
+            </a:r>
+          </a:p>
+          <a:p>
+            <a:pPr marL="800100" lvl="1" indent="-342900">
+              <a:buFont typeface="Courier New" panose="020B0604020202020204" pitchFamily="34" charset="0"/>
+              <a:buChar char="o"/>
+            </a:pPr>
+            <a:r>
+              <a:rPr lang="en-GB" dirty="0">
+                <a:latin typeface="Arial"/>
+                <a:cs typeface="Arial"/>
+              </a:rPr>
+              <a:t>Existing visualization paradigms where people have already tried doing these</a:t>
+            </a:r>
+          </a:p>
+          <a:p>
+            <a:pPr marL="342900" indent="-342900">
+              <a:buFont typeface="Arial" panose="020B0604020202020204" pitchFamily="34" charset="0"/>
+              <a:buChar char="•"/>
+            </a:pPr>
+            <a:r>
+              <a:rPr lang="en-GB" dirty="0"/>
+              <a:t>How fluid can fill this gap -&gt; how will this help future neuroscience research</a:t>
+            </a:r>
+          </a:p>
+          <a:p>
+            <a:pPr marL="342900" indent="-342900">
+              <a:buFont typeface="Arial" panose="020B0604020202020204" pitchFamily="34" charset="0"/>
+              <a:buChar char="•"/>
+            </a:pPr>
+            <a:r>
+              <a:rPr lang="en-GB" dirty="0">
+                <a:latin typeface="Arial"/>
+                <a:cs typeface="Arial"/>
+              </a:rPr>
+              <a:t>Functions such as multiple cascading visualizations between input and the output, multi-level selection of datapoints</a:t>
+            </a:r>
+          </a:p>
+          <a:p>
+            <a:pPr marL="342900" indent="-342900">
+              <a:buFont typeface="Arial" panose="020B0604020202020204" pitchFamily="34" charset="0"/>
+              <a:buChar char="•"/>
+            </a:pPr>
+            <a:r>
+              <a:rPr lang="en-GB" dirty="0">
+                <a:latin typeface="Arial"/>
+                <a:cs typeface="Arial"/>
+              </a:rPr>
+              <a:t>Funding opportunities</a:t>
+            </a:r>
+          </a:p>
+        </p:txBody>
+      </p:sp>
+    </p:spTree>
+    <p:extLst>
+      <p:ext uri="{BB962C8B-B14F-4D97-AF65-F5344CB8AC3E}">
+        <p14:creationId xmlns:p14="http://schemas.microsoft.com/office/powerpoint/2010/main" val="2060602487"/>
+      </p:ext>
+    </p:extLst>
+  </p:cSld>
+  <p:clrMapOvr>
+    <a:masterClrMapping/>
+  </p:clrMapOvr>
+</p:sld>
+</file>
+
 <file path=ppt/slides/slide7.xml><?xml version="1.0" encoding="utf-8"?>
 <p:sld xmlns:a="http://schemas.openxmlformats.org/drawingml/2006/main" xmlns:r="http://schemas.openxmlformats.org/officeDocument/2006/relationships" xmlns:p="http://schemas.openxmlformats.org/presentationml/2006/main">
   <p:cSld>
@@ -7909,7 +9145,7 @@
           <p:cNvPr id="2" name="Title 1">
             <a:extLst>
               <a:ext uri="{FF2B5EF4-FFF2-40B4-BE49-F238E27FC236}">
-                <a16:creationId xmlns:a16="http://schemas.microsoft.com/office/drawing/2014/main" id="{A100F8FC-5333-9FD7-0F73-41F50092BD06}"/>
+                <a16:creationId xmlns:a16="http://schemas.microsoft.com/office/drawing/2014/main" id="{85F1938B-ABA9-A998-BEBD-414D693D356B}"/>
               </a:ext>
             </a:extLst>
           </p:cNvPr>
@@ -7920,14 +9156,19 @@
             <p:ph type="title"/>
           </p:nvPr>
         </p:nvSpPr>
-        <p:spPr/>
+        <p:spPr>
+          <a:xfrm>
+            <a:off x="502919" y="220147"/>
+            <a:ext cx="9921240" cy="478155"/>
+          </a:xfrm>
+        </p:spPr>
         <p:txBody>
           <a:bodyPr/>
           <a:lstStyle/>
           <a:p>
             <a:r>
               <a:rPr lang="en-GB" dirty="0"/>
-              <a:t>Future work</a:t>
+              <a:t>Neuroscience Research Output (Abstractions)</a:t>
             </a:r>
           </a:p>
         </p:txBody>
@@ -7937,7 +9178,7 @@
           <p:cNvPr id="3" name="Content Placeholder 2">
             <a:extLst>
               <a:ext uri="{FF2B5EF4-FFF2-40B4-BE49-F238E27FC236}">
-                <a16:creationId xmlns:a16="http://schemas.microsoft.com/office/drawing/2014/main" id="{B5F85657-1037-47E1-2518-F114ADD35137}"/>
+                <a16:creationId xmlns:a16="http://schemas.microsoft.com/office/drawing/2014/main" id="{F6CA6B60-A9F9-2AD8-3316-6015B4533613}"/>
               </a:ext>
             </a:extLst>
           </p:cNvPr>
@@ -7948,93 +9189,582 @@
             <p:ph sz="half" idx="1"/>
           </p:nvPr>
         </p:nvSpPr>
-        <p:spPr/>
+        <p:spPr>
+          <a:xfrm>
+            <a:off x="973701" y="915585"/>
+            <a:ext cx="2575258" cy="4378960"/>
+          </a:xfrm>
+        </p:spPr>
         <p:txBody>
-          <a:bodyPr vert="horz" lIns="91440" tIns="45720" rIns="91440" bIns="45720" rtlCol="0" anchor="t">
-            <a:normAutofit/>
+          <a:bodyPr>
+            <a:noAutofit/>
           </a:bodyPr>
           <a:lstStyle/>
           <a:p>
-            <a:pPr marL="342900" indent="-342900">
-              <a:buFont typeface="Arial" panose="020B0604020202020204" pitchFamily="34" charset="0"/>
-              <a:buChar char="•"/>
-            </a:pPr>
-            <a:r>
-              <a:rPr lang="en-GB" dirty="0">
-                <a:latin typeface="Arial"/>
-                <a:cs typeface="Arial"/>
-              </a:rPr>
-              <a:t>Identify different types of output artefacts in neuroscience research.</a:t>
-            </a:r>
-          </a:p>
-          <a:p>
-            <a:pPr marL="342900" indent="-342900">
-              <a:buFont typeface="Arial" panose="020B0604020202020204" pitchFamily="34" charset="0"/>
-              <a:buChar char="•"/>
-            </a:pPr>
-            <a:r>
-              <a:rPr lang="en-GB" dirty="0">
-                <a:latin typeface="Arial"/>
-                <a:cs typeface="Arial"/>
-              </a:rPr>
-              <a:t>Literature survey on if/how there is a disconnect between neuroscience research outputs and data.</a:t>
-            </a:r>
-          </a:p>
-          <a:p>
-            <a:pPr marL="800100" lvl="1" indent="-342900">
-              <a:buFont typeface="Courier New" panose="020B0604020202020204" pitchFamily="34" charset="0"/>
-              <a:buChar char="o"/>
-            </a:pPr>
-            <a:r>
-              <a:rPr lang="en-GB" dirty="0">
-                <a:latin typeface="Arial"/>
-                <a:cs typeface="Arial"/>
-              </a:rPr>
-              <a:t>Existing visualization paradigms where people have already tried doing these</a:t>
-            </a:r>
-          </a:p>
-          <a:p>
-            <a:pPr marL="342900" indent="-342900">
-              <a:buFont typeface="Arial" panose="020B0604020202020204" pitchFamily="34" charset="0"/>
-              <a:buChar char="•"/>
-            </a:pPr>
-            <a:r>
-              <a:rPr lang="en-GB" dirty="0"/>
-              <a:t>How fluid can fill this gap -&gt; how will this help future neuroscience research</a:t>
-            </a:r>
-          </a:p>
-          <a:p>
-            <a:pPr marL="342900" indent="-342900">
-              <a:buFont typeface="Arial" panose="020B0604020202020204" pitchFamily="34" charset="0"/>
-              <a:buChar char="•"/>
-            </a:pPr>
-            <a:r>
-              <a:rPr lang="en-GB" dirty="0">
-                <a:latin typeface="Arial"/>
-                <a:cs typeface="Arial"/>
-              </a:rPr>
-              <a:t>Functions such as multiple cascading visualizations between input and the output, multi-level selection of datapoints</a:t>
-            </a:r>
-          </a:p>
-          <a:p>
-            <a:pPr marL="342900" indent="-342900">
-              <a:buFont typeface="Arial" panose="020B0604020202020204" pitchFamily="34" charset="0"/>
-              <a:buChar char="•"/>
-            </a:pPr>
-            <a:r>
-              <a:rPr lang="en-GB" dirty="0">
-                <a:latin typeface="Arial"/>
-                <a:cs typeface="Arial"/>
-              </a:rPr>
-              <a:t>Funding opportunities</a:t>
-            </a:r>
+            <a:r>
+              <a:rPr lang="en-GB" sz="800" b="1" dirty="0"/>
+              <a:t>1. Output artefacts in EEG / MEG experiments</a:t>
+            </a:r>
+          </a:p>
+          <a:p>
+            <a:r>
+              <a:rPr lang="en-GB" sz="800" b="1" dirty="0"/>
+              <a:t>A. Sensor-space artefacts (directly observable)</a:t>
+            </a:r>
+          </a:p>
+          <a:p>
+            <a:r>
+              <a:rPr lang="en-GB" sz="800" dirty="0"/>
+              <a:t>Raw sensor time-series plots</a:t>
+            </a:r>
+          </a:p>
+          <a:p>
+            <a:r>
+              <a:rPr lang="en-GB" sz="800" dirty="0" err="1"/>
+              <a:t>Epoched</a:t>
+            </a:r>
+            <a:r>
+              <a:rPr lang="en-GB" sz="800" dirty="0"/>
+              <a:t> sensor waveforms (per condition / trial average)</a:t>
+            </a:r>
+          </a:p>
+          <a:p>
+            <a:r>
+              <a:rPr lang="en-GB" sz="800" dirty="0"/>
+              <a:t>Butterfly plots</a:t>
+            </a:r>
+          </a:p>
+          <a:p>
+            <a:r>
+              <a:rPr lang="en-GB" sz="800" dirty="0"/>
+              <a:t>Sensor-level scalp maps (topographies)</a:t>
+            </a:r>
+          </a:p>
+          <a:p>
+            <a:r>
+              <a:rPr lang="en-GB" sz="800" dirty="0"/>
+              <a:t>Sensor-level time–frequency maps (ERSP / induced power)</a:t>
+            </a:r>
+          </a:p>
+          <a:p>
+            <a:r>
+              <a:rPr lang="en-GB" sz="800" dirty="0"/>
+              <a:t>Evoked response plots (ERP / ERF)</a:t>
+            </a:r>
+          </a:p>
+          <a:p>
+            <a:r>
+              <a:rPr lang="en-GB" sz="800" dirty="0"/>
+              <a:t>Global field power (GFP) curves</a:t>
+            </a:r>
+          </a:p>
+          <a:p>
+            <a:r>
+              <a:rPr lang="en-GB" sz="800" dirty="0"/>
+              <a:t>Inter-trial phase coherence (ITPC / PLV at sensor level)</a:t>
+            </a:r>
+          </a:p>
+          <a:p>
+            <a:br>
+              <a:rPr lang="en-GB" sz="800" dirty="0"/>
+            </a:br>
+            <a:endParaRPr lang="en-GB" sz="800" dirty="0"/>
+          </a:p>
+          <a:p>
+            <a:r>
+              <a:rPr lang="en-GB" sz="800" b="1" dirty="0"/>
+              <a:t>B. Time–frequency &amp; spectral artefacts</a:t>
+            </a:r>
+          </a:p>
+          <a:p>
+            <a:r>
+              <a:rPr lang="en-GB" sz="800" dirty="0"/>
+              <a:t>Power spectral density (PSD) plots</a:t>
+            </a:r>
+          </a:p>
+          <a:p>
+            <a:r>
+              <a:rPr lang="en-GB" sz="800" dirty="0"/>
+              <a:t>Band-limited power summaries (</a:t>
+            </a:r>
+            <a:r>
+              <a:rPr lang="el-GR" sz="800" dirty="0"/>
+              <a:t>δ, θ, α, β, γ)</a:t>
+            </a:r>
+          </a:p>
+          <a:p>
+            <a:r>
+              <a:rPr lang="en-GB" sz="800" dirty="0"/>
+              <a:t>Time–frequency spectrograms</a:t>
+            </a:r>
+          </a:p>
+          <a:p>
+            <a:r>
+              <a:rPr lang="en-GB" sz="800" dirty="0"/>
+              <a:t>Cross-frequency coupling maps (PAC, AAC, PPC)</a:t>
+            </a:r>
+          </a:p>
+          <a:p>
+            <a:r>
+              <a:rPr lang="en-GB" sz="800" dirty="0"/>
+              <a:t>Frequency-specific topographies</a:t>
+            </a:r>
+          </a:p>
+          <a:p>
+            <a:r>
+              <a:rPr lang="en-GB" sz="800" dirty="0"/>
+              <a:t>Spectral slope / aperiodic (1/f) parameter maps</a:t>
+            </a:r>
+          </a:p>
+          <a:p>
+            <a:br>
+              <a:rPr lang="en-GB" sz="800" dirty="0"/>
+            </a:br>
+            <a:endParaRPr lang="en-GB" sz="800" dirty="0"/>
+          </a:p>
+          <a:p>
+            <a:endParaRPr lang="en-GB" sz="800" dirty="0"/>
+          </a:p>
+        </p:txBody>
+      </p:sp>
+      <p:sp>
+        <p:nvSpPr>
+          <p:cNvPr id="4" name="TextBox 3">
+            <a:extLst>
+              <a:ext uri="{FF2B5EF4-FFF2-40B4-BE49-F238E27FC236}">
+                <a16:creationId xmlns:a16="http://schemas.microsoft.com/office/drawing/2014/main" id="{EB5FC45A-0781-EBD3-58A6-B7B4181D836F}"/>
+              </a:ext>
+            </a:extLst>
+          </p:cNvPr>
+          <p:cNvSpPr txBox="1"/>
+          <p:nvPr/>
+        </p:nvSpPr>
+        <p:spPr>
+          <a:xfrm>
+            <a:off x="3892764" y="898663"/>
+            <a:ext cx="3141551" cy="3662541"/>
+          </a:xfrm>
+          <a:prstGeom prst="rect">
+            <a:avLst/>
+          </a:prstGeom>
+          <a:noFill/>
+        </p:spPr>
+        <p:txBody>
+          <a:bodyPr wrap="square" rtlCol="0">
+            <a:spAutoFit/>
+          </a:bodyPr>
+          <a:lstStyle/>
+          <a:p>
+            <a:r>
+              <a:rPr lang="en-GB" sz="800" b="1" dirty="0"/>
+              <a:t>C. Source-space artefacts (EEG/MEG only)</a:t>
+            </a:r>
+          </a:p>
+          <a:p>
+            <a:r>
+              <a:rPr lang="en-GB" sz="800" dirty="0"/>
+              <a:t>Source-localized activity maps (dipoles, distributed sources)</a:t>
+            </a:r>
+          </a:p>
+          <a:p>
+            <a:r>
+              <a:rPr lang="en-GB" sz="800" dirty="0"/>
+              <a:t>Source time-series plots</a:t>
+            </a:r>
+          </a:p>
+          <a:p>
+            <a:r>
+              <a:rPr lang="en-GB" sz="800" dirty="0"/>
+              <a:t>Source-space evoked responses</a:t>
+            </a:r>
+          </a:p>
+          <a:p>
+            <a:r>
+              <a:rPr lang="en-GB" sz="800" dirty="0"/>
+              <a:t>Source-level time–frequency maps</a:t>
+            </a:r>
+          </a:p>
+          <a:p>
+            <a:r>
+              <a:rPr lang="en-GB" sz="800" dirty="0"/>
+              <a:t>Region-wise activation summaries (atlas-based)</a:t>
+            </a:r>
+          </a:p>
+          <a:p>
+            <a:r>
+              <a:rPr lang="en-GB" sz="800" dirty="0"/>
+              <a:t>Source power contrast maps (condition A vs B)</a:t>
+            </a:r>
+          </a:p>
+          <a:p>
+            <a:br>
+              <a:rPr lang="en-GB" sz="800" dirty="0"/>
+            </a:br>
+            <a:endParaRPr lang="en-GB" sz="800" dirty="0"/>
+          </a:p>
+          <a:p>
+            <a:r>
+              <a:rPr lang="en-GB" sz="800" b="1" dirty="0"/>
+              <a:t>D. Functional connectivity artefacts</a:t>
+            </a:r>
+          </a:p>
+          <a:p>
+            <a:r>
+              <a:rPr lang="en-GB" sz="800" b="1" dirty="0"/>
+              <a:t>Sensor-space</a:t>
+            </a:r>
+          </a:p>
+          <a:p>
+            <a:r>
+              <a:rPr lang="en-GB" sz="800" dirty="0"/>
+              <a:t>Sensor-level connectivity matrices</a:t>
+            </a:r>
+          </a:p>
+          <a:p>
+            <a:r>
+              <a:rPr lang="en-GB" sz="800" dirty="0"/>
+              <a:t>Frequency-resolved connectivity graphs</a:t>
+            </a:r>
+          </a:p>
+          <a:p>
+            <a:r>
+              <a:rPr lang="en-GB" sz="800" dirty="0"/>
+              <a:t>Time-resolved connectivity maps</a:t>
+            </a:r>
+          </a:p>
+          <a:p>
+            <a:r>
+              <a:rPr lang="en-GB" sz="800" b="1" dirty="0"/>
+              <a:t>Source-space</a:t>
+            </a:r>
+          </a:p>
+          <a:p>
+            <a:r>
+              <a:rPr lang="en-GB" sz="800" dirty="0"/>
+              <a:t>Source-level connectivity matrices</a:t>
+            </a:r>
+          </a:p>
+          <a:p>
+            <a:r>
+              <a:rPr lang="en-GB" sz="800" dirty="0"/>
+              <a:t>ROI-to-ROI connectivity graphs</a:t>
+            </a:r>
+          </a:p>
+          <a:p>
+            <a:r>
+              <a:rPr lang="en-GB" sz="800" dirty="0"/>
+              <a:t>Dynamic functional connectivity plots</a:t>
+            </a:r>
+          </a:p>
+          <a:p>
+            <a:r>
+              <a:rPr lang="en-GB" sz="800" dirty="0"/>
+              <a:t>Network-specific connectivity visualizations</a:t>
+            </a:r>
+          </a:p>
+          <a:p>
+            <a:r>
+              <a:rPr lang="en-GB" sz="800" dirty="0"/>
+              <a:t>Metrics (outputs may encode):</a:t>
+            </a:r>
+          </a:p>
+          <a:p>
+            <a:r>
+              <a:rPr lang="en-GB" sz="800" dirty="0"/>
+              <a:t>Coherence</a:t>
+            </a:r>
+          </a:p>
+          <a:p>
+            <a:r>
+              <a:rPr lang="en-GB" sz="800" dirty="0"/>
+              <a:t>Imaginary coherence</a:t>
+            </a:r>
+          </a:p>
+          <a:p>
+            <a:r>
+              <a:rPr lang="en-GB" sz="800" dirty="0"/>
+              <a:t>Phase-locking value (PLV)</a:t>
+            </a:r>
+          </a:p>
+          <a:p>
+            <a:r>
+              <a:rPr lang="en-GB" sz="800" dirty="0"/>
+              <a:t>Amplitude envelope correlation</a:t>
+            </a:r>
+          </a:p>
+          <a:p>
+            <a:r>
+              <a:rPr lang="en-GB" sz="800" dirty="0"/>
+              <a:t>Granger causality (frequency-resolved)</a:t>
+            </a:r>
+          </a:p>
+          <a:p>
+            <a:r>
+              <a:rPr lang="en-GB" sz="800" dirty="0"/>
+              <a:t>Transfer entropy (if used)</a:t>
+            </a:r>
+          </a:p>
+          <a:p>
+            <a:br>
+              <a:rPr lang="en-GB" sz="800" dirty="0"/>
+            </a:br>
+            <a:endParaRPr lang="en-GB" sz="800" dirty="0"/>
+          </a:p>
+          <a:p>
+            <a:endParaRPr lang="en-GB" sz="800" dirty="0"/>
+          </a:p>
+        </p:txBody>
+      </p:sp>
+      <p:sp>
+        <p:nvSpPr>
+          <p:cNvPr id="5" name="TextBox 4">
+            <a:extLst>
+              <a:ext uri="{FF2B5EF4-FFF2-40B4-BE49-F238E27FC236}">
+                <a16:creationId xmlns:a16="http://schemas.microsoft.com/office/drawing/2014/main" id="{4DEB64E5-F18B-B5FB-9EA8-217EB3F6C71E}"/>
+              </a:ext>
+            </a:extLst>
+          </p:cNvPr>
+          <p:cNvSpPr txBox="1"/>
+          <p:nvPr/>
+        </p:nvSpPr>
+        <p:spPr>
+          <a:xfrm>
+            <a:off x="6744831" y="898663"/>
+            <a:ext cx="2701381" cy="5016758"/>
+          </a:xfrm>
+          <a:prstGeom prst="rect">
+            <a:avLst/>
+          </a:prstGeom>
+          <a:noFill/>
+        </p:spPr>
+        <p:txBody>
+          <a:bodyPr wrap="none" rtlCol="0">
+            <a:spAutoFit/>
+          </a:bodyPr>
+          <a:lstStyle/>
+          <a:p>
+            <a:r>
+              <a:rPr lang="en-GB" sz="800" b="1" dirty="0"/>
+              <a:t>E. Network &amp; graph-theoretic artefacts</a:t>
+            </a:r>
+          </a:p>
+          <a:p>
+            <a:r>
+              <a:rPr lang="en-GB" sz="800" dirty="0"/>
+              <a:t>Functional brain network graphs</a:t>
+            </a:r>
+          </a:p>
+          <a:p>
+            <a:r>
+              <a:rPr lang="en-GB" sz="800" dirty="0"/>
+              <a:t>Community / module assignments</a:t>
+            </a:r>
+          </a:p>
+          <a:p>
+            <a:r>
+              <a:rPr lang="en-GB" sz="800" dirty="0"/>
+              <a:t>Hub / centrality maps</a:t>
+            </a:r>
+          </a:p>
+          <a:p>
+            <a:r>
+              <a:rPr lang="en-GB" sz="800" dirty="0"/>
+              <a:t>Network efficiency plots</a:t>
+            </a:r>
+          </a:p>
+          <a:p>
+            <a:r>
+              <a:rPr lang="en-GB" sz="800" dirty="0"/>
+              <a:t>Rich-club structure visualizations</a:t>
+            </a:r>
+          </a:p>
+          <a:p>
+            <a:r>
+              <a:rPr lang="en-GB" sz="800" dirty="0"/>
+              <a:t>Network dynamics over time</a:t>
+            </a:r>
+          </a:p>
+          <a:p>
+            <a:br>
+              <a:rPr lang="en-GB" sz="800" dirty="0"/>
+            </a:br>
+            <a:endParaRPr lang="en-GB" sz="800" dirty="0"/>
+          </a:p>
+          <a:p>
+            <a:r>
+              <a:rPr lang="en-GB" sz="800" b="1" dirty="0"/>
+              <a:t>F. Statistical artefacts</a:t>
+            </a:r>
+          </a:p>
+          <a:p>
+            <a:r>
+              <a:rPr lang="en-GB" sz="800" dirty="0"/>
+              <a:t>Contrast maps (condition differences)</a:t>
+            </a:r>
+          </a:p>
+          <a:p>
+            <a:r>
+              <a:rPr lang="en-GB" sz="800" dirty="0"/>
+              <a:t>Statistical parametric maps (t, z, F)</a:t>
+            </a:r>
+          </a:p>
+          <a:p>
+            <a:r>
+              <a:rPr lang="en-GB" sz="800" dirty="0"/>
+              <a:t>Cluster-based permutation results</a:t>
+            </a:r>
+          </a:p>
+          <a:p>
+            <a:r>
+              <a:rPr lang="en-GB" sz="800" dirty="0"/>
+              <a:t>Confidence interval visualizations</a:t>
+            </a:r>
+          </a:p>
+          <a:p>
+            <a:r>
+              <a:rPr lang="en-GB" sz="800" dirty="0"/>
+              <a:t>Effect size maps</a:t>
+            </a:r>
+          </a:p>
+          <a:p>
+            <a:r>
+              <a:rPr lang="en-GB" sz="800" dirty="0" err="1"/>
+              <a:t>Thresholded</a:t>
+            </a:r>
+            <a:r>
+              <a:rPr lang="en-GB" sz="800" dirty="0"/>
+              <a:t> significance maps</a:t>
+            </a:r>
+          </a:p>
+          <a:p>
+            <a:br>
+              <a:rPr lang="en-GB" sz="800" dirty="0"/>
+            </a:br>
+            <a:endParaRPr lang="en-GB" sz="800" dirty="0"/>
+          </a:p>
+          <a:p>
+            <a:r>
+              <a:rPr lang="en-GB" sz="800" b="1" dirty="0"/>
+              <a:t>G. Task / event-locked artefacts</a:t>
+            </a:r>
+          </a:p>
+          <a:p>
+            <a:r>
+              <a:rPr lang="en-GB" sz="800" dirty="0"/>
+              <a:t>Event-related potential / field components (e.g. P300, N170)</a:t>
+            </a:r>
+          </a:p>
+          <a:p>
+            <a:r>
+              <a:rPr lang="en-GB" sz="800" dirty="0"/>
+              <a:t>Latency maps</a:t>
+            </a:r>
+          </a:p>
+          <a:p>
+            <a:r>
+              <a:rPr lang="en-GB" sz="800" dirty="0"/>
+              <a:t>Peak amplitude distributions</a:t>
+            </a:r>
+          </a:p>
+          <a:p>
+            <a:r>
+              <a:rPr lang="en-GB" sz="800" dirty="0"/>
+              <a:t>Trial-wise variability plots</a:t>
+            </a:r>
+          </a:p>
+          <a:p>
+            <a:r>
+              <a:rPr lang="en-GB" sz="800" dirty="0"/>
+              <a:t>Response-locked averages</a:t>
+            </a:r>
+          </a:p>
+          <a:p>
+            <a:br>
+              <a:rPr lang="en-GB" sz="800" dirty="0"/>
+            </a:br>
+            <a:endParaRPr lang="en-GB" sz="800" dirty="0"/>
+          </a:p>
+          <a:p>
+            <a:r>
+              <a:rPr lang="en-GB" sz="800" b="1" dirty="0"/>
+              <a:t>H. Model-derived artefacts (EEG/MEG-specific)</a:t>
+            </a:r>
+          </a:p>
+          <a:p>
+            <a:r>
+              <a:rPr lang="en-GB" sz="800" dirty="0"/>
+              <a:t>Neural mass / neural field model outputs</a:t>
+            </a:r>
+          </a:p>
+          <a:p>
+            <a:r>
+              <a:rPr lang="en-GB" sz="800" dirty="0"/>
+              <a:t>Model parameter maps</a:t>
+            </a:r>
+          </a:p>
+          <a:p>
+            <a:r>
+              <a:rPr lang="en-GB" sz="800" dirty="0"/>
+              <a:t>Simulated vs observed signal comparisons</a:t>
+            </a:r>
+          </a:p>
+          <a:p>
+            <a:r>
+              <a:rPr lang="en-GB" sz="800" dirty="0"/>
+              <a:t>Forward-model predicted sensor patterns</a:t>
+            </a:r>
+          </a:p>
+          <a:p>
+            <a:r>
+              <a:rPr lang="en-GB" sz="800" dirty="0"/>
+              <a:t>Residual/error maps</a:t>
+            </a:r>
+          </a:p>
+          <a:p>
+            <a:br>
+              <a:rPr lang="en-GB" sz="800" dirty="0"/>
+            </a:br>
+            <a:endParaRPr lang="en-GB" sz="800" dirty="0"/>
+          </a:p>
+          <a:p>
+            <a:r>
+              <a:rPr lang="en-GB" sz="800" b="1" dirty="0"/>
+              <a:t>I. Multimodal-within-EEG/MEG artefacts</a:t>
+            </a:r>
+          </a:p>
+          <a:p>
+            <a:r>
+              <a:rPr lang="en-GB" sz="800" dirty="0"/>
+              <a:t>EEG–MEG correspondence maps</a:t>
+            </a:r>
+          </a:p>
+          <a:p>
+            <a:r>
+              <a:rPr lang="en-GB" sz="800" dirty="0"/>
+              <a:t>Cross-sensor-type coherence</a:t>
+            </a:r>
+          </a:p>
+          <a:p>
+            <a:r>
+              <a:rPr lang="en-GB" sz="800" dirty="0"/>
+              <a:t>Joint source reconstructions</a:t>
+            </a:r>
+          </a:p>
+          <a:p>
+            <a:r>
+              <a:rPr lang="en-GB" sz="800" dirty="0"/>
+              <a:t>Modality-specific contribution maps</a:t>
+            </a:r>
+          </a:p>
+          <a:p>
+            <a:endParaRPr lang="en-GB" sz="800" dirty="0"/>
           </a:p>
         </p:txBody>
       </p:sp>
     </p:spTree>
     <p:extLst>
       <p:ext uri="{BB962C8B-B14F-4D97-AF65-F5344CB8AC3E}">
-        <p14:creationId xmlns:p14="http://schemas.microsoft.com/office/powerpoint/2010/main" val="2060602487"/>
+        <p14:creationId xmlns:p14="http://schemas.microsoft.com/office/powerpoint/2010/main" val="440742937"/>
       </p:ext>
     </p:extLst>
   </p:cSld>
@@ -8066,7 +9796,7 @@
           <p:cNvPr id="2" name="Title 1">
             <a:extLst>
               <a:ext uri="{FF2B5EF4-FFF2-40B4-BE49-F238E27FC236}">
-                <a16:creationId xmlns:a16="http://schemas.microsoft.com/office/drawing/2014/main" id="{85F1938B-ABA9-A998-BEBD-414D693D356B}"/>
+                <a16:creationId xmlns:a16="http://schemas.microsoft.com/office/drawing/2014/main" id="{CB686F0F-2558-6CD4-ED34-C2081FF05248}"/>
               </a:ext>
             </a:extLst>
           </p:cNvPr>
@@ -8077,20 +9807,16 @@
             <p:ph type="title"/>
           </p:nvPr>
         </p:nvSpPr>
-        <p:spPr>
-          <a:xfrm>
-            <a:off x="502919" y="220147"/>
-            <a:ext cx="9921240" cy="478155"/>
-          </a:xfrm>
-        </p:spPr>
+        <p:spPr/>
         <p:txBody>
           <a:bodyPr/>
           <a:lstStyle/>
           <a:p>
             <a:r>
-              <a:rPr lang="en-GB" dirty="0"/>
-              <a:t>Neuroscience Research Output (Abstractions)</a:t>
-            </a:r>
+              <a:rPr lang="en-GB"/>
+              <a:t>Progress after 12/01/26</a:t>
+            </a:r>
+            <a:endParaRPr lang="en-GB" dirty="0"/>
           </a:p>
         </p:txBody>
       </p:sp>
@@ -8099,7 +9825,7 @@
           <p:cNvPr id="3" name="Content Placeholder 2">
             <a:extLst>
               <a:ext uri="{FF2B5EF4-FFF2-40B4-BE49-F238E27FC236}">
-                <a16:creationId xmlns:a16="http://schemas.microsoft.com/office/drawing/2014/main" id="{F6CA6B60-A9F9-2AD8-3316-6015B4533613}"/>
+                <a16:creationId xmlns:a16="http://schemas.microsoft.com/office/drawing/2014/main" id="{45E231A9-DF66-F654-6D8C-9F7A8D20CDFE}"/>
               </a:ext>
             </a:extLst>
           </p:cNvPr>
@@ -8110,582 +9836,319 @@
             <p:ph sz="half" idx="1"/>
           </p:nvPr>
         </p:nvSpPr>
-        <p:spPr>
-          <a:xfrm>
-            <a:off x="973701" y="915585"/>
-            <a:ext cx="2575258" cy="4378960"/>
-          </a:xfrm>
-        </p:spPr>
+        <p:spPr/>
         <p:txBody>
-          <a:bodyPr>
-            <a:noAutofit/>
-          </a:bodyPr>
+          <a:bodyPr/>
           <a:lstStyle/>
           <a:p>
-            <a:r>
-              <a:rPr lang="en-GB" sz="800" b="1" dirty="0"/>
-              <a:t>1. Output artefacts in EEG / MEG experiments</a:t>
-            </a:r>
-          </a:p>
-          <a:p>
-            <a:r>
-              <a:rPr lang="en-GB" sz="800" b="1" dirty="0"/>
-              <a:t>A. Sensor-space artefacts (directly observable)</a:t>
-            </a:r>
-          </a:p>
-          <a:p>
-            <a:r>
-              <a:rPr lang="en-GB" sz="800" dirty="0"/>
-              <a:t>Raw sensor time-series plots</a:t>
-            </a:r>
-          </a:p>
-          <a:p>
-            <a:r>
-              <a:rPr lang="en-GB" sz="800" dirty="0" err="1"/>
-              <a:t>Epoched</a:t>
-            </a:r>
-            <a:r>
-              <a:rPr lang="en-GB" sz="800" dirty="0"/>
-              <a:t> sensor waveforms (per condition / trial average)</a:t>
-            </a:r>
-          </a:p>
-          <a:p>
-            <a:r>
-              <a:rPr lang="en-GB" sz="800" dirty="0"/>
-              <a:t>Butterfly plots</a:t>
-            </a:r>
-          </a:p>
-          <a:p>
-            <a:r>
-              <a:rPr lang="en-GB" sz="800" dirty="0"/>
-              <a:t>Sensor-level scalp maps (topographies)</a:t>
-            </a:r>
-          </a:p>
-          <a:p>
-            <a:r>
-              <a:rPr lang="en-GB" sz="800" dirty="0"/>
-              <a:t>Sensor-level time–frequency maps (ERSP / induced power)</a:t>
-            </a:r>
-          </a:p>
-          <a:p>
-            <a:r>
-              <a:rPr lang="en-GB" sz="800" dirty="0"/>
-              <a:t>Evoked response plots (ERP / ERF)</a:t>
-            </a:r>
-          </a:p>
-          <a:p>
-            <a:r>
-              <a:rPr lang="en-GB" sz="800" dirty="0"/>
-              <a:t>Global field power (GFP) curves</a:t>
-            </a:r>
-          </a:p>
-          <a:p>
-            <a:r>
-              <a:rPr lang="en-GB" sz="800" dirty="0"/>
-              <a:t>Inter-trial phase coherence (ITPC / PLV at sensor level)</a:t>
-            </a:r>
-          </a:p>
-          <a:p>
-            <a:br>
-              <a:rPr lang="en-GB" sz="800" dirty="0"/>
-            </a:br>
-            <a:endParaRPr lang="en-GB" sz="800" dirty="0"/>
-          </a:p>
-          <a:p>
-            <a:r>
-              <a:rPr lang="en-GB" sz="800" b="1" dirty="0"/>
-              <a:t>B. Time–frequency &amp; spectral artefacts</a:t>
-            </a:r>
-          </a:p>
-          <a:p>
-            <a:r>
-              <a:rPr lang="en-GB" sz="800" dirty="0"/>
-              <a:t>Power spectral density (PSD) plots</a:t>
-            </a:r>
-          </a:p>
-          <a:p>
-            <a:r>
-              <a:rPr lang="en-GB" sz="800" dirty="0"/>
-              <a:t>Band-limited power summaries (</a:t>
-            </a:r>
-            <a:r>
-              <a:rPr lang="el-GR" sz="800" dirty="0"/>
-              <a:t>δ, θ, α, β, γ)</a:t>
-            </a:r>
-          </a:p>
-          <a:p>
-            <a:r>
-              <a:rPr lang="en-GB" sz="800" dirty="0"/>
-              <a:t>Time–frequency spectrograms</a:t>
-            </a:r>
-          </a:p>
-          <a:p>
-            <a:r>
-              <a:rPr lang="en-GB" sz="800" dirty="0"/>
-              <a:t>Cross-frequency coupling maps (PAC, AAC, PPC)</a:t>
-            </a:r>
-          </a:p>
-          <a:p>
-            <a:r>
-              <a:rPr lang="en-GB" sz="800" dirty="0"/>
-              <a:t>Frequency-specific topographies</a:t>
-            </a:r>
-          </a:p>
-          <a:p>
-            <a:r>
-              <a:rPr lang="en-GB" sz="800" dirty="0"/>
-              <a:t>Spectral slope / aperiodic (1/f) parameter maps</a:t>
-            </a:r>
-          </a:p>
-          <a:p>
-            <a:br>
-              <a:rPr lang="en-GB" sz="800" dirty="0"/>
-            </a:br>
-            <a:endParaRPr lang="en-GB" sz="800" dirty="0"/>
-          </a:p>
-          <a:p>
-            <a:endParaRPr lang="en-GB" sz="800" dirty="0"/>
-          </a:p>
-        </p:txBody>
-      </p:sp>
-      <p:sp>
-        <p:nvSpPr>
-          <p:cNvPr id="4" name="TextBox 3">
-            <a:extLst>
-              <a:ext uri="{FF2B5EF4-FFF2-40B4-BE49-F238E27FC236}">
-                <a16:creationId xmlns:a16="http://schemas.microsoft.com/office/drawing/2014/main" id="{EB5FC45A-0781-EBD3-58A6-B7B4181D836F}"/>
-              </a:ext>
-            </a:extLst>
-          </p:cNvPr>
-          <p:cNvSpPr txBox="1"/>
-          <p:nvPr/>
-        </p:nvSpPr>
-        <p:spPr>
-          <a:xfrm>
-            <a:off x="3892764" y="898663"/>
-            <a:ext cx="3141551" cy="3662541"/>
-          </a:xfrm>
-          <a:prstGeom prst="rect">
-            <a:avLst/>
-          </a:prstGeom>
-          <a:noFill/>
-        </p:spPr>
-        <p:txBody>
-          <a:bodyPr wrap="square" rtlCol="0">
-            <a:spAutoFit/>
-          </a:bodyPr>
-          <a:lstStyle/>
-          <a:p>
-            <a:r>
-              <a:rPr lang="en-GB" sz="800" b="1" dirty="0"/>
-              <a:t>C. Source-space artefacts (EEG/MEG only)</a:t>
-            </a:r>
-          </a:p>
-          <a:p>
-            <a:r>
-              <a:rPr lang="en-GB" sz="800" dirty="0"/>
-              <a:t>Source-localized activity maps (dipoles, distributed sources)</a:t>
-            </a:r>
-          </a:p>
-          <a:p>
-            <a:r>
-              <a:rPr lang="en-GB" sz="800" dirty="0"/>
-              <a:t>Source time-series plots</a:t>
-            </a:r>
-          </a:p>
-          <a:p>
-            <a:r>
-              <a:rPr lang="en-GB" sz="800" dirty="0"/>
-              <a:t>Source-space evoked responses</a:t>
-            </a:r>
-          </a:p>
-          <a:p>
-            <a:r>
-              <a:rPr lang="en-GB" sz="800" dirty="0"/>
-              <a:t>Source-level time–frequency maps</a:t>
-            </a:r>
-          </a:p>
-          <a:p>
-            <a:r>
-              <a:rPr lang="en-GB" sz="800" dirty="0"/>
-              <a:t>Region-wise activation summaries (atlas-based)</a:t>
-            </a:r>
-          </a:p>
-          <a:p>
-            <a:r>
-              <a:rPr lang="en-GB" sz="800" dirty="0"/>
-              <a:t>Source power contrast maps (condition A vs B)</a:t>
-            </a:r>
-          </a:p>
-          <a:p>
-            <a:br>
-              <a:rPr lang="en-GB" sz="800" dirty="0"/>
-            </a:br>
-            <a:endParaRPr lang="en-GB" sz="800" dirty="0"/>
-          </a:p>
-          <a:p>
-            <a:r>
-              <a:rPr lang="en-GB" sz="800" b="1" dirty="0"/>
-              <a:t>D. Functional connectivity artefacts</a:t>
-            </a:r>
-          </a:p>
-          <a:p>
-            <a:r>
-              <a:rPr lang="en-GB" sz="800" b="1" dirty="0"/>
-              <a:t>Sensor-space</a:t>
-            </a:r>
-          </a:p>
-          <a:p>
-            <a:r>
-              <a:rPr lang="en-GB" sz="800" dirty="0"/>
-              <a:t>Sensor-level connectivity matrices</a:t>
-            </a:r>
-          </a:p>
-          <a:p>
-            <a:r>
-              <a:rPr lang="en-GB" sz="800" dirty="0"/>
-              <a:t>Frequency-resolved connectivity graphs</a:t>
-            </a:r>
-          </a:p>
-          <a:p>
-            <a:r>
-              <a:rPr lang="en-GB" sz="800" dirty="0"/>
-              <a:t>Time-resolved connectivity maps</a:t>
-            </a:r>
-          </a:p>
-          <a:p>
-            <a:r>
-              <a:rPr lang="en-GB" sz="800" b="1" dirty="0"/>
-              <a:t>Source-space</a:t>
-            </a:r>
-          </a:p>
-          <a:p>
-            <a:r>
-              <a:rPr lang="en-GB" sz="800" dirty="0"/>
-              <a:t>Source-level connectivity matrices</a:t>
-            </a:r>
-          </a:p>
-          <a:p>
-            <a:r>
-              <a:rPr lang="en-GB" sz="800" dirty="0"/>
-              <a:t>ROI-to-ROI connectivity graphs</a:t>
-            </a:r>
-          </a:p>
-          <a:p>
-            <a:r>
-              <a:rPr lang="en-GB" sz="800" dirty="0"/>
-              <a:t>Dynamic functional connectivity plots</a:t>
-            </a:r>
-          </a:p>
-          <a:p>
-            <a:r>
-              <a:rPr lang="en-GB" sz="800" dirty="0"/>
-              <a:t>Network-specific connectivity visualizations</a:t>
-            </a:r>
-          </a:p>
-          <a:p>
-            <a:r>
-              <a:rPr lang="en-GB" sz="800" dirty="0"/>
-              <a:t>Metrics (outputs may encode):</a:t>
-            </a:r>
-          </a:p>
-          <a:p>
-            <a:r>
-              <a:rPr lang="en-GB" sz="800" dirty="0"/>
-              <a:t>Coherence</a:t>
-            </a:r>
-          </a:p>
-          <a:p>
-            <a:r>
-              <a:rPr lang="en-GB" sz="800" dirty="0"/>
-              <a:t>Imaginary coherence</a:t>
-            </a:r>
-          </a:p>
-          <a:p>
-            <a:r>
-              <a:rPr lang="en-GB" sz="800" dirty="0"/>
-              <a:t>Phase-locking value (PLV)</a:t>
-            </a:r>
-          </a:p>
-          <a:p>
-            <a:r>
-              <a:rPr lang="en-GB" sz="800" dirty="0"/>
-              <a:t>Amplitude envelope correlation</a:t>
-            </a:r>
-          </a:p>
-          <a:p>
-            <a:r>
-              <a:rPr lang="en-GB" sz="800" dirty="0"/>
-              <a:t>Granger causality (frequency-resolved)</a:t>
-            </a:r>
-          </a:p>
-          <a:p>
-            <a:r>
-              <a:rPr lang="en-GB" sz="800" dirty="0"/>
-              <a:t>Transfer entropy (if used)</a:t>
-            </a:r>
-          </a:p>
-          <a:p>
-            <a:br>
-              <a:rPr lang="en-GB" sz="800" dirty="0"/>
-            </a:br>
-            <a:endParaRPr lang="en-GB" sz="800" dirty="0"/>
-          </a:p>
-          <a:p>
-            <a:endParaRPr lang="en-GB" sz="800" dirty="0"/>
-          </a:p>
-        </p:txBody>
-      </p:sp>
-      <p:sp>
-        <p:nvSpPr>
-          <p:cNvPr id="5" name="TextBox 4">
-            <a:extLst>
-              <a:ext uri="{FF2B5EF4-FFF2-40B4-BE49-F238E27FC236}">
-                <a16:creationId xmlns:a16="http://schemas.microsoft.com/office/drawing/2014/main" id="{4DEB64E5-F18B-B5FB-9EA8-217EB3F6C71E}"/>
-              </a:ext>
-            </a:extLst>
-          </p:cNvPr>
-          <p:cNvSpPr txBox="1"/>
-          <p:nvPr/>
-        </p:nvSpPr>
-        <p:spPr>
-          <a:xfrm>
-            <a:off x="6744831" y="898663"/>
-            <a:ext cx="2701381" cy="5016758"/>
-          </a:xfrm>
-          <a:prstGeom prst="rect">
-            <a:avLst/>
-          </a:prstGeom>
-          <a:noFill/>
-        </p:spPr>
-        <p:txBody>
-          <a:bodyPr wrap="none" rtlCol="0">
-            <a:spAutoFit/>
-          </a:bodyPr>
-          <a:lstStyle/>
-          <a:p>
-            <a:r>
-              <a:rPr lang="en-GB" sz="800" b="1" dirty="0"/>
-              <a:t>E. Network &amp; graph-theoretic artefacts</a:t>
-            </a:r>
-          </a:p>
-          <a:p>
-            <a:r>
-              <a:rPr lang="en-GB" sz="800" dirty="0"/>
-              <a:t>Functional brain network graphs</a:t>
-            </a:r>
-          </a:p>
-          <a:p>
-            <a:r>
-              <a:rPr lang="en-GB" sz="800" dirty="0"/>
-              <a:t>Community / module assignments</a:t>
-            </a:r>
-          </a:p>
-          <a:p>
-            <a:r>
-              <a:rPr lang="en-GB" sz="800" dirty="0"/>
-              <a:t>Hub / centrality maps</a:t>
-            </a:r>
-          </a:p>
-          <a:p>
-            <a:r>
-              <a:rPr lang="en-GB" sz="800" dirty="0"/>
-              <a:t>Network efficiency plots</a:t>
-            </a:r>
-          </a:p>
-          <a:p>
-            <a:r>
-              <a:rPr lang="en-GB" sz="800" dirty="0"/>
-              <a:t>Rich-club structure visualizations</a:t>
-            </a:r>
-          </a:p>
-          <a:p>
-            <a:r>
-              <a:rPr lang="en-GB" sz="800" dirty="0"/>
-              <a:t>Network dynamics over time</a:t>
-            </a:r>
-          </a:p>
-          <a:p>
-            <a:br>
-              <a:rPr lang="en-GB" sz="800" dirty="0"/>
-            </a:br>
-            <a:endParaRPr lang="en-GB" sz="800" dirty="0"/>
-          </a:p>
-          <a:p>
-            <a:r>
-              <a:rPr lang="en-GB" sz="800" b="1" dirty="0"/>
-              <a:t>F. Statistical artefacts</a:t>
-            </a:r>
-          </a:p>
-          <a:p>
-            <a:r>
-              <a:rPr lang="en-GB" sz="800" dirty="0"/>
-              <a:t>Contrast maps (condition differences)</a:t>
-            </a:r>
-          </a:p>
-          <a:p>
-            <a:r>
-              <a:rPr lang="en-GB" sz="800" dirty="0"/>
-              <a:t>Statistical parametric maps (t, z, F)</a:t>
-            </a:r>
-          </a:p>
-          <a:p>
-            <a:r>
-              <a:rPr lang="en-GB" sz="800" dirty="0"/>
-              <a:t>Cluster-based permutation results</a:t>
-            </a:r>
-          </a:p>
-          <a:p>
-            <a:r>
-              <a:rPr lang="en-GB" sz="800" dirty="0"/>
-              <a:t>Confidence interval visualizations</a:t>
-            </a:r>
-          </a:p>
-          <a:p>
-            <a:r>
-              <a:rPr lang="en-GB" sz="800" dirty="0"/>
-              <a:t>Effect size maps</a:t>
-            </a:r>
-          </a:p>
-          <a:p>
-            <a:r>
-              <a:rPr lang="en-GB" sz="800" dirty="0" err="1"/>
-              <a:t>Thresholded</a:t>
-            </a:r>
-            <a:r>
-              <a:rPr lang="en-GB" sz="800" dirty="0"/>
-              <a:t> significance maps</a:t>
-            </a:r>
-          </a:p>
-          <a:p>
-            <a:br>
-              <a:rPr lang="en-GB" sz="800" dirty="0"/>
-            </a:br>
-            <a:endParaRPr lang="en-GB" sz="800" dirty="0"/>
-          </a:p>
-          <a:p>
-            <a:r>
-              <a:rPr lang="en-GB" sz="800" b="1" dirty="0"/>
-              <a:t>G. Task / event-locked artefacts</a:t>
-            </a:r>
-          </a:p>
-          <a:p>
-            <a:r>
-              <a:rPr lang="en-GB" sz="800" dirty="0"/>
-              <a:t>Event-related potential / field components (e.g. P300, N170)</a:t>
-            </a:r>
-          </a:p>
-          <a:p>
-            <a:r>
-              <a:rPr lang="en-GB" sz="800" dirty="0"/>
-              <a:t>Latency maps</a:t>
-            </a:r>
-          </a:p>
-          <a:p>
-            <a:r>
-              <a:rPr lang="en-GB" sz="800" dirty="0"/>
-              <a:t>Peak amplitude distributions</a:t>
-            </a:r>
-          </a:p>
-          <a:p>
-            <a:r>
-              <a:rPr lang="en-GB" sz="800" dirty="0"/>
-              <a:t>Trial-wise variability plots</a:t>
-            </a:r>
-          </a:p>
-          <a:p>
-            <a:r>
-              <a:rPr lang="en-GB" sz="800" dirty="0"/>
-              <a:t>Response-locked averages</a:t>
-            </a:r>
-          </a:p>
-          <a:p>
-            <a:br>
-              <a:rPr lang="en-GB" sz="800" dirty="0"/>
-            </a:br>
-            <a:endParaRPr lang="en-GB" sz="800" dirty="0"/>
-          </a:p>
-          <a:p>
-            <a:r>
-              <a:rPr lang="en-GB" sz="800" b="1" dirty="0"/>
-              <a:t>H. Model-derived artefacts (EEG/MEG-specific)</a:t>
-            </a:r>
-          </a:p>
-          <a:p>
-            <a:r>
-              <a:rPr lang="en-GB" sz="800" dirty="0"/>
-              <a:t>Neural mass / neural field model outputs</a:t>
-            </a:r>
-          </a:p>
-          <a:p>
-            <a:r>
-              <a:rPr lang="en-GB" sz="800" dirty="0"/>
-              <a:t>Model parameter maps</a:t>
-            </a:r>
-          </a:p>
-          <a:p>
-            <a:r>
-              <a:rPr lang="en-GB" sz="800" dirty="0"/>
-              <a:t>Simulated vs observed signal comparisons</a:t>
-            </a:r>
-          </a:p>
-          <a:p>
-            <a:r>
-              <a:rPr lang="en-GB" sz="800" dirty="0"/>
-              <a:t>Forward-model predicted sensor patterns</a:t>
-            </a:r>
-          </a:p>
-          <a:p>
-            <a:r>
-              <a:rPr lang="en-GB" sz="800" dirty="0"/>
-              <a:t>Residual/error maps</a:t>
-            </a:r>
-          </a:p>
-          <a:p>
-            <a:br>
-              <a:rPr lang="en-GB" sz="800" dirty="0"/>
-            </a:br>
-            <a:endParaRPr lang="en-GB" sz="800" dirty="0"/>
-          </a:p>
-          <a:p>
-            <a:r>
-              <a:rPr lang="en-GB" sz="800" b="1" dirty="0"/>
-              <a:t>I. Multimodal-within-EEG/MEG artefacts</a:t>
-            </a:r>
-          </a:p>
-          <a:p>
-            <a:r>
-              <a:rPr lang="en-GB" sz="800" dirty="0"/>
-              <a:t>EEG–MEG correspondence maps</a:t>
-            </a:r>
-          </a:p>
-          <a:p>
-            <a:r>
-              <a:rPr lang="en-GB" sz="800" dirty="0"/>
-              <a:t>Cross-sensor-type coherence</a:t>
-            </a:r>
-          </a:p>
-          <a:p>
-            <a:r>
-              <a:rPr lang="en-GB" sz="800" dirty="0"/>
-              <a:t>Joint source reconstructions</a:t>
-            </a:r>
-          </a:p>
-          <a:p>
-            <a:r>
-              <a:rPr lang="en-GB" sz="800" dirty="0"/>
-              <a:t>Modality-specific contribution maps</a:t>
-            </a:r>
-          </a:p>
-          <a:p>
-            <a:endParaRPr lang="en-GB" sz="800" dirty="0"/>
+            <a:pPr marL="342900" indent="-342900">
+              <a:buFont typeface="Arial" panose="020B0604020202020204" pitchFamily="34" charset="0"/>
+              <a:buChar char="•"/>
+            </a:pPr>
+            <a:r>
+              <a:rPr lang="en-GB" dirty="0"/>
+              <a:t>Decided to use my MSc thesis output as the base for simulation</a:t>
+            </a:r>
+          </a:p>
+          <a:p>
+            <a:pPr marL="800100" lvl="1" indent="-342900">
+              <a:buFont typeface="Arial" panose="020B0604020202020204" pitchFamily="34" charset="0"/>
+              <a:buChar char="•"/>
+            </a:pPr>
+            <a:r>
+              <a:rPr lang="en-GB" dirty="0"/>
+              <a:t>Not discussed the idea with my supervisor yet</a:t>
+            </a:r>
+          </a:p>
+          <a:p>
+            <a:pPr marL="800100" lvl="1" indent="-342900">
+              <a:buFont typeface="Arial" panose="020B0604020202020204" pitchFamily="34" charset="0"/>
+              <a:buChar char="•"/>
+            </a:pPr>
+            <a:endParaRPr lang="en-GB" dirty="0"/>
+          </a:p>
+          <a:p>
+            <a:pPr marL="342900" indent="-342900">
+              <a:buFont typeface="Arial" panose="020B0604020202020204" pitchFamily="34" charset="0"/>
+              <a:buChar char="•"/>
+            </a:pPr>
+            <a:r>
+              <a:rPr lang="en-GB" dirty="0"/>
+              <a:t>Setting up of repository</a:t>
+            </a:r>
+          </a:p>
+          <a:p>
+            <a:pPr marL="800100" lvl="1" indent="-342900">
+              <a:buFont typeface="Arial" panose="020B0604020202020204" pitchFamily="34" charset="0"/>
+              <a:buChar char="•"/>
+            </a:pPr>
+            <a:r>
+              <a:rPr lang="en-GB" dirty="0"/>
+              <a:t>Created </a:t>
+            </a:r>
+            <a:r>
+              <a:rPr lang="en-GB" dirty="0" err="1"/>
+              <a:t>github</a:t>
+            </a:r>
+            <a:r>
+              <a:rPr lang="en-GB" dirty="0"/>
+              <a:t> organization, to host all relevant repositories</a:t>
+            </a:r>
+          </a:p>
+          <a:p>
+            <a:pPr marL="800100" lvl="1" indent="-342900">
+              <a:buFont typeface="Arial" panose="020B0604020202020204" pitchFamily="34" charset="0"/>
+              <a:buChar char="•"/>
+            </a:pPr>
+            <a:r>
+              <a:rPr lang="en-GB" dirty="0"/>
+              <a:t>Admin access to Roly</a:t>
+            </a:r>
+          </a:p>
+          <a:p>
+            <a:pPr marL="800100" lvl="1" indent="-342900">
+              <a:buFont typeface="Arial" panose="020B0604020202020204" pitchFamily="34" charset="0"/>
+              <a:buChar char="•"/>
+            </a:pPr>
+            <a:r>
+              <a:rPr lang="en-GB" dirty="0"/>
+              <a:t>Example website added</a:t>
+            </a:r>
+          </a:p>
+          <a:p>
+            <a:pPr marL="800100" lvl="1" indent="-342900">
+              <a:buFont typeface="Arial" panose="020B0604020202020204" pitchFamily="34" charset="0"/>
+              <a:buChar char="•"/>
+            </a:pPr>
+            <a:r>
+              <a:rPr lang="en-GB" dirty="0"/>
+              <a:t>Local building and testing of website done</a:t>
+            </a:r>
+          </a:p>
+          <a:p>
+            <a:pPr marL="800100" lvl="1" indent="-342900">
+              <a:buFont typeface="Arial" panose="020B0604020202020204" pitchFamily="34" charset="0"/>
+              <a:buChar char="•"/>
+            </a:pPr>
+            <a:endParaRPr lang="en-GB" dirty="0"/>
+          </a:p>
+          <a:p>
+            <a:pPr marL="342900" indent="-342900">
+              <a:buFont typeface="Arial" panose="020B0604020202020204" pitchFamily="34" charset="0"/>
+              <a:buChar char="•"/>
+            </a:pPr>
+            <a:r>
+              <a:rPr lang="en-GB" dirty="0"/>
+              <a:t>Keeping it simple in the beginning</a:t>
+            </a:r>
+          </a:p>
+          <a:p>
+            <a:pPr marL="800100" lvl="1" indent="-342900">
+              <a:buFont typeface="Arial" panose="020B0604020202020204" pitchFamily="34" charset="0"/>
+              <a:buChar char="•"/>
+            </a:pPr>
+            <a:r>
+              <a:rPr lang="en-GB" dirty="0"/>
+              <a:t>Using only EEG/functional connectivity data to visualize.</a:t>
+            </a:r>
+          </a:p>
+          <a:p>
+            <a:pPr marL="800100" lvl="1" indent="-342900">
+              <a:buFont typeface="Arial" panose="020B0604020202020204" pitchFamily="34" charset="0"/>
+              <a:buChar char="•"/>
+            </a:pPr>
+            <a:r>
+              <a:rPr lang="en-GB" dirty="0"/>
+              <a:t>Currently trying to add </a:t>
+            </a:r>
+            <a:r>
+              <a:rPr lang="en-GB" dirty="0" err="1"/>
+              <a:t>eeg</a:t>
+            </a:r>
+            <a:r>
+              <a:rPr lang="en-GB" dirty="0"/>
+              <a:t>-coherence example to the website</a:t>
+            </a:r>
           </a:p>
         </p:txBody>
       </p:sp>
     </p:spTree>
     <p:extLst>
       <p:ext uri="{BB962C8B-B14F-4D97-AF65-F5344CB8AC3E}">
-        <p14:creationId xmlns:p14="http://schemas.microsoft.com/office/powerpoint/2010/main" val="440742937"/>
+        <p14:creationId xmlns:p14="http://schemas.microsoft.com/office/powerpoint/2010/main" val="870742400"/>
+      </p:ext>
+    </p:extLst>
+  </p:cSld>
+  <p:clrMapOvr>
+    <a:masterClrMapping/>
+  </p:clrMapOvr>
+</p:sld>
+</file>
+
+<file path=ppt/slides/slide9.xml><?xml version="1.0" encoding="utf-8"?>
+<p:sld xmlns:a="http://schemas.openxmlformats.org/drawingml/2006/main" xmlns:r="http://schemas.openxmlformats.org/officeDocument/2006/relationships" xmlns:p="http://schemas.openxmlformats.org/presentationml/2006/main">
+  <p:cSld>
+    <p:spTree>
+      <p:nvGrpSpPr>
+        <p:cNvPr id="1" name="">
+          <a:extLst>
+            <a:ext uri="{FF2B5EF4-FFF2-40B4-BE49-F238E27FC236}">
+              <a16:creationId xmlns:a16="http://schemas.microsoft.com/office/drawing/2014/main" id="{3F2A408D-FB65-D666-3D9C-27714A983B75}"/>
+            </a:ext>
+          </a:extLst>
+        </p:cNvPr>
+        <p:cNvGrpSpPr/>
+        <p:nvPr/>
+      </p:nvGrpSpPr>
+      <p:grpSpPr>
+        <a:xfrm>
+          <a:off x="0" y="0"/>
+          <a:ext cx="0" cy="0"/>
+          <a:chOff x="0" y="0"/>
+          <a:chExt cx="0" cy="0"/>
+        </a:xfrm>
+      </p:grpSpPr>
+      <p:sp>
+        <p:nvSpPr>
+          <p:cNvPr id="2" name="Title 1">
+            <a:extLst>
+              <a:ext uri="{FF2B5EF4-FFF2-40B4-BE49-F238E27FC236}">
+                <a16:creationId xmlns:a16="http://schemas.microsoft.com/office/drawing/2014/main" id="{4D3664AA-54E0-ED59-7BF6-C42E9302AAE9}"/>
+              </a:ext>
+            </a:extLst>
+          </p:cNvPr>
+          <p:cNvSpPr>
+            <a:spLocks noGrp="1"/>
+          </p:cNvSpPr>
+          <p:nvPr>
+            <p:ph type="title"/>
+          </p:nvPr>
+        </p:nvSpPr>
+        <p:spPr/>
+        <p:txBody>
+          <a:bodyPr/>
+          <a:lstStyle/>
+          <a:p>
+            <a:r>
+              <a:rPr lang="en-GB" dirty="0"/>
+              <a:t>Progress after 19/03/2026</a:t>
+            </a:r>
+          </a:p>
+        </p:txBody>
+      </p:sp>
+      <p:sp>
+        <p:nvSpPr>
+          <p:cNvPr id="3" name="Content Placeholder 2">
+            <a:extLst>
+              <a:ext uri="{FF2B5EF4-FFF2-40B4-BE49-F238E27FC236}">
+                <a16:creationId xmlns:a16="http://schemas.microsoft.com/office/drawing/2014/main" id="{C366A86C-1738-1720-9801-A780A6A4C673}"/>
+              </a:ext>
+            </a:extLst>
+          </p:cNvPr>
+          <p:cNvSpPr>
+            <a:spLocks noGrp="1"/>
+          </p:cNvSpPr>
+          <p:nvPr>
+            <p:ph sz="half" idx="1"/>
+          </p:nvPr>
+        </p:nvSpPr>
+        <p:spPr/>
+        <p:txBody>
+          <a:bodyPr>
+            <a:normAutofit lnSpcReduction="10000"/>
+          </a:bodyPr>
+          <a:lstStyle/>
+          <a:p>
+            <a:pPr marL="342900" indent="-342900">
+              <a:buFont typeface="Arial" panose="020B0604020202020204" pitchFamily="34" charset="0"/>
+              <a:buChar char="•"/>
+            </a:pPr>
+            <a:r>
+              <a:rPr lang="en-GB" dirty="0"/>
+              <a:t>Found open-source dataset where single participant somatosensory response after motor taps was recorded using MEG system (magnetic activity whereas EEG measures electrical activity)</a:t>
+            </a:r>
+          </a:p>
+          <a:p>
+            <a:pPr marL="342900" indent="-342900">
+              <a:buFont typeface="Arial" panose="020B0604020202020204" pitchFamily="34" charset="0"/>
+              <a:buChar char="•"/>
+            </a:pPr>
+            <a:r>
+              <a:rPr lang="en-GB" dirty="0"/>
+              <a:t>Dataset available at : </a:t>
+            </a:r>
+            <a:r>
+              <a:rPr lang="en-GB" dirty="0">
+                <a:hlinkClick r:id="rId2"/>
+              </a:rPr>
+              <a:t>https://mne.tools/stable/generated/mne.datasets.somato.data_path.html#mne.datasets.somato.data_path</a:t>
+            </a:r>
+            <a:endParaRPr lang="en-GB" dirty="0"/>
+          </a:p>
+          <a:p>
+            <a:pPr marL="342900" indent="-342900">
+              <a:buFont typeface="Arial" panose="020B0604020202020204" pitchFamily="34" charset="0"/>
+              <a:buChar char="•"/>
+            </a:pPr>
+            <a:r>
+              <a:rPr lang="en-GB" dirty="0"/>
+              <a:t>Processing script available at : </a:t>
+            </a:r>
+            <a:r>
+              <a:rPr lang="en-GB" dirty="0">
+                <a:hlinkClick r:id="rId3"/>
+              </a:rPr>
+              <a:t>https://mne.tools/stable/auto_tutorials/time-freq/20_sensors_time_frequency.html#tut-sensors-time-freq</a:t>
+            </a:r>
+            <a:endParaRPr lang="en-GB" dirty="0"/>
+          </a:p>
+          <a:p>
+            <a:pPr marL="342900" indent="-342900">
+              <a:buFont typeface="Arial" panose="020B0604020202020204" pitchFamily="34" charset="0"/>
+              <a:buChar char="•"/>
+            </a:pPr>
+            <a:r>
+              <a:rPr lang="en-GB" dirty="0"/>
+              <a:t>This script will be updated to generated coherence dataset that will be used for website example : </a:t>
+            </a:r>
+            <a:r>
+              <a:rPr lang="en-GB" dirty="0" err="1"/>
+              <a:t>eeg</a:t>
+            </a:r>
+            <a:r>
+              <a:rPr lang="en-GB" dirty="0"/>
+              <a:t>-coherence (details next slide)</a:t>
+            </a:r>
+          </a:p>
+          <a:p>
+            <a:pPr marL="800100" lvl="1" indent="-342900">
+              <a:buFont typeface="Arial" panose="020B0604020202020204" pitchFamily="34" charset="0"/>
+              <a:buChar char="•"/>
+            </a:pPr>
+            <a:r>
+              <a:rPr lang="en-GB" dirty="0"/>
+              <a:t>Better to write a </a:t>
+            </a:r>
+            <a:r>
+              <a:rPr lang="en-GB" dirty="0" err="1"/>
+              <a:t>jupyter</a:t>
+            </a:r>
+            <a:r>
+              <a:rPr lang="en-GB" dirty="0"/>
+              <a:t> notebook to integrate with </a:t>
+            </a:r>
+            <a:r>
+              <a:rPr lang="en-GB" dirty="0" err="1"/>
+              <a:t>CurveNote</a:t>
+            </a:r>
+            <a:endParaRPr lang="en-GB" dirty="0"/>
+          </a:p>
+        </p:txBody>
+      </p:sp>
+    </p:spTree>
+    <p:extLst>
+      <p:ext uri="{BB962C8B-B14F-4D97-AF65-F5344CB8AC3E}">
+        <p14:creationId xmlns:p14="http://schemas.microsoft.com/office/powerpoint/2010/main" val="755755287"/>
       </p:ext>
     </p:extLst>
   </p:cSld>

</xml_diff>